<commit_message>
Rewrite Session 3, 4 and 5 decks
Co-Authored-By: Claude Sonnet 5.5 <noreply@anthropic.com>
</commit_message>
<xml_diff>
--- a/materials/slides/session-5.pptx
+++ b/materials/slides/session-5.pptx
@@ -25,7 +25,6 @@
     <p:sldId id="273" r:id="rId24"/>
     <p:sldId id="274" r:id="rId25"/>
     <p:sldId id="275" r:id="rId26"/>
-    <p:sldId id="276" r:id="rId27"/>
   </p:sldIdLst>
   <p:sldSz cx="12191999" cy="6858000" type="screen4x3"/>
   <p:notesSz cx="6858000" cy="9144000"/>
@@ -3481,7 +3480,7 @@
                 </a:solidFill>
                 <a:latin typeface="Arial"/>
               </a:rPr>
-              <a:t>Use your own repository, dataset, and question in groups of </a:t>
+              <a:t>Use your own Backend repo, dataset, and question in groups of </a:t>
             </a:r>
             <a:br/>
             <a:r>
@@ -3825,7 +3824,7 @@
                 </a:solidFill>
                 <a:latin typeface="Courier New"/>
               </a:rPr>
-              <a:t>CSV upload -&gt; Streamlit -&gt; HTTP request -&gt; FastAPI</a:t>
+              <a:t>CSV upload -&gt; Frontend page -&gt; HTTP request -&gt; FastAPI</a:t>
             </a:r>
           </a:p>
         </p:txBody>
@@ -3878,7 +3877,7 @@
                 </a:solidFill>
                 <a:latin typeface="Courier New"/>
               </a:rPr>
-              <a:t>FastAPI -&gt; reusable stat_core processing -&gt; result</a:t>
+              <a:t>FastAPI -&gt; package processing function -&gt; result</a:t>
             </a:r>
           </a:p>
         </p:txBody>
@@ -3931,7 +3930,7 @@
                 </a:solidFill>
                 <a:latin typeface="Courier New"/>
               </a:rPr>
-              <a:t>result -&gt; Streamlit -&gt; visible records/summary/chart</a:t>
+              <a:t>result -&gt; page -&gt; visible table or chart</a:t>
             </a:r>
           </a:p>
         </p:txBody>
@@ -3983,7 +3982,7 @@
                 </a:solidFill>
                 <a:latin typeface="Arial"/>
               </a:rPr>
-              <a:t>HTTP carries requests and responses between programs; </a:t>
+              <a:t>HTTP carries requests and responses between programs; the </a:t>
             </a:r>
             <a:br/>
             <a:r>
@@ -3993,7 +3992,7 @@
                 </a:solidFill>
                 <a:latin typeface="Arial"/>
               </a:rPr>
-              <a:t>reusable processing functions work without the API or UI.</a:t>
+              <a:t>processing function works without the API or the page.</a:t>
             </a:r>
           </a:p>
         </p:txBody>
@@ -4007,7 +4006,7 @@
         <p:spPr>
           <a:xfrm>
             <a:off x="594360" y="3715511"/>
-            <a:ext cx="11003279" cy="780288"/>
+            <a:ext cx="11003279" cy="1132332"/>
           </a:xfrm>
           <a:prstGeom prst="rect">
             <a:avLst/>
@@ -4045,65 +4044,27 @@
                 </a:solidFill>
                 <a:latin typeface="Arial"/>
               </a:rPr>
-              <a:t>Instructor follows one request through </a:t>
-            </a:r>
-            <a:r>
-              <a:rPr sz="2100" b="0" i="0">
-                <a:solidFill>
-                  <a:srgbClr val="007F82"/>
-                </a:solidFill>
-                <a:latin typeface="Arial"/>
-                <a:hlinkClick r:id="rId2"/>
-              </a:rPr>
-              <a:t>frontend</a:t>
-            </a:r>
-            <a:r>
-              <a:rPr sz="2100" b="0" i="0">
-                <a:solidFill>
-                  <a:srgbClr val="20344A"/>
-                </a:solidFill>
-                <a:latin typeface="Arial"/>
-              </a:rPr>
-              <a:t>, </a:t>
-            </a:r>
-            <a:r>
-              <a:rPr sz="2100" b="0" i="0">
-                <a:solidFill>
-                  <a:srgbClr val="007F82"/>
-                </a:solidFill>
-                <a:latin typeface="Arial"/>
-                <a:hlinkClick r:id="rId3"/>
-              </a:rPr>
-              <a:t>API</a:t>
-            </a:r>
-            <a:r>
-              <a:rPr sz="2100" b="0" i="0">
-                <a:solidFill>
-                  <a:srgbClr val="20344A"/>
-                </a:solidFill>
-                <a:latin typeface="Arial"/>
-              </a:rPr>
-              <a:t>, and </a:t>
+              <a:t>Instructor follows one request through the Frontend repo's </a:t>
             </a:r>
             <a:br/>
             <a:r>
               <a:rPr sz="2100" b="0" i="0">
                 <a:solidFill>
-                  <a:srgbClr val="007F82"/>
-                </a:solidFill>
-                <a:latin typeface="Arial"/>
-                <a:hlinkClick r:id="rId4"/>
-              </a:rPr>
-              <a:t>package</a:t>
-            </a:r>
-            <a:r>
-              <a:rPr sz="2100" b="0" i="0">
-                <a:solidFill>
-                  <a:srgbClr val="20344A"/>
-                </a:solidFill>
-                <a:latin typeface="Arial"/>
-              </a:rPr>
-              <a:t>, checking inputs and returned results.</a:t>
+                  <a:srgbClr val="20344A"/>
+                </a:solidFill>
+                <a:latin typeface="Arial"/>
+              </a:rPr>
+              <a:t>client, your API module, and your package, checking inputs and </a:t>
+            </a:r>
+            <a:br/>
+            <a:r>
+              <a:rPr sz="2100" b="0" i="0">
+                <a:solidFill>
+                  <a:srgbClr val="20344A"/>
+                </a:solidFill>
+                <a:latin typeface="Arial"/>
+              </a:rPr>
+              <a:t>returned results.</a:t>
             </a:r>
           </a:p>
         </p:txBody>
@@ -4116,7 +4077,7 @@
         </p:nvSpPr>
         <p:spPr>
           <a:xfrm>
-            <a:off x="594360" y="4559808"/>
+            <a:off x="594360" y="4911851"/>
             <a:ext cx="11003279" cy="780288"/>
           </a:xfrm>
           <a:prstGeom prst="rect">
@@ -4445,7 +4406,7 @@
                 </a:solidFill>
                 <a:latin typeface="Arial"/>
               </a:rPr>
-              <a:t> live; show frontend/backend </a:t>
+              <a:t> live; show both services </a:t>
             </a:r>
             <a:br/>
             <a:r>
@@ -4535,7 +4496,7 @@
                 </a:solidFill>
                 <a:latin typeface="Arial"/>
               </a:rPr>
-              <a:t>; frontend calls </a:t>
+              <a:t>; the page calls </a:t>
             </a:r>
             <a:br/>
             <a:r>
@@ -4564,7 +4525,7 @@
                 </a:solidFill>
                 <a:latin typeface="Arial"/>
               </a:rPr>
-              <a:t>the frontend itself.</a:t>
+              <a:t>the page itself.</a:t>
             </a:r>
           </a:p>
         </p:txBody>
@@ -4578,6 +4539,58 @@
         <p:spPr>
           <a:xfrm>
             <a:off x="594360" y="4130040"/>
+            <a:ext cx="11003279" cy="428244"/>
+          </a:xfrm>
+          <a:prstGeom prst="rect">
+            <a:avLst/>
+          </a:prstGeom>
+          <a:noFill/>
+        </p:spPr>
+        <p:txBody>
+          <a:bodyPr wrap="none" anchor="t" lIns="88900" rIns="88900" tIns="38100" bIns="38100">
+            <a:noAutofit/>
+          </a:bodyPr>
+          <a:lstStyle/>
+          <a:p>
+            <a:pPr marL="279400" indent="-215900">
+              <a:lnSpc>
+                <a:spcPts val="2772"/>
+              </a:lnSpc>
+              <a:spcBef>
+                <a:spcPts val="0"/>
+              </a:spcBef>
+              <a:spcAft>
+                <a:spcPts val="0"/>
+              </a:spcAft>
+              <a:defRPr sz="2100">
+                <a:solidFill>
+                  <a:srgbClr val="20344A"/>
+                </a:solidFill>
+                <a:latin typeface="Arial"/>
+              </a:defRPr>
+              <a:buChar char="•"/>
+            </a:pPr>
+            <a:r>
+              <a:rPr sz="2100" b="0" i="0">
+                <a:solidFill>
+                  <a:srgbClr val="20344A"/>
+                </a:solidFill>
+                <a:latin typeface="Arial"/>
+              </a:rPr>
+              <a:t>Upload your group's CSV and show the results or a chart.</a:t>
+            </a:r>
+          </a:p>
+        </p:txBody>
+      </p:sp>
+      <p:sp>
+        <p:nvSpPr>
+          <p:cNvPr id="9" name="content:line-93:0"/>
+          <p:cNvSpPr txBox="1"/>
+          <p:nvPr/>
+        </p:nvSpPr>
+        <p:spPr>
+          <a:xfrm>
+            <a:off x="594360" y="4622292"/>
             <a:ext cx="11003279" cy="1132332"/>
           </a:xfrm>
           <a:prstGeom prst="rect">
@@ -4616,7 +4629,7 @@
                 </a:solidFill>
                 <a:latin typeface="Arial"/>
               </a:rPr>
-              <a:t>Upload and process CSVs; show results or a chart. In the </a:t>
+              <a:t>Instructor inspects actual service communication and output, </a:t>
             </a:r>
             <a:br/>
             <a:r>
@@ -4626,7 +4639,7 @@
                 </a:solidFill>
                 <a:latin typeface="Arial"/>
               </a:rPr>
-              <a:t>supplied example, upload DM and LB: 24 participants, 96 </a:t>
+              <a:t>not only configuration. Stop standalone servers using the same </a:t>
             </a:r>
             <a:br/>
             <a:r>
@@ -4636,88 +4649,7 @@
                 </a:solidFill>
                 <a:latin typeface="Arial"/>
               </a:rPr>
-              <a:t>records, 95 observed, 1 missing.</a:t>
-            </a:r>
-          </a:p>
-        </p:txBody>
-      </p:sp>
-      <p:sp>
-        <p:nvSpPr>
-          <p:cNvPr id="9" name="content:line-93:0"/>
-          <p:cNvSpPr txBox="1"/>
-          <p:nvPr/>
-        </p:nvSpPr>
-        <p:spPr>
-          <a:xfrm>
-            <a:off x="594360" y="5326380"/>
-            <a:ext cx="11003279" cy="780288"/>
-          </a:xfrm>
-          <a:prstGeom prst="rect">
-            <a:avLst/>
-          </a:prstGeom>
-          <a:noFill/>
-        </p:spPr>
-        <p:txBody>
-          <a:bodyPr wrap="none" anchor="t" lIns="88900" rIns="88900" tIns="38100" bIns="38100">
-            <a:noAutofit/>
-          </a:bodyPr>
-          <a:lstStyle/>
-          <a:p>
-            <a:pPr marL="279400" indent="-215900">
-              <a:lnSpc>
-                <a:spcPts val="2772"/>
-              </a:lnSpc>
-              <a:spcBef>
-                <a:spcPts val="0"/>
-              </a:spcBef>
-              <a:spcAft>
-                <a:spcPts val="0"/>
-              </a:spcAft>
-              <a:defRPr sz="2100">
-                <a:solidFill>
-                  <a:srgbClr val="20344A"/>
-                </a:solidFill>
-                <a:latin typeface="Arial"/>
-              </a:defRPr>
-              <a:buChar char="•"/>
-            </a:pPr>
-            <a:r>
-              <a:rPr sz="2100" b="0" i="0">
-                <a:solidFill>
-                  <a:srgbClr val="20344A"/>
-                </a:solidFill>
-                <a:latin typeface="Arial"/>
-              </a:rPr>
-              <a:t>Instructor inspects actual service communication and output, </a:t>
-            </a:r>
-            <a:br/>
-            <a:r>
-              <a:rPr sz="2100" b="0" i="0">
-                <a:solidFill>
-                  <a:srgbClr val="20344A"/>
-                </a:solidFill>
-                <a:latin typeface="Arial"/>
-              </a:rPr>
-              <a:t>not only configuration. Follow the </a:t>
-            </a:r>
-            <a:r>
-              <a:rPr sz="2100" b="0" i="0">
-                <a:solidFill>
-                  <a:srgbClr val="007F82"/>
-                </a:solidFill>
-                <a:latin typeface="Arial"/>
-                <a:hlinkClick r:id="rId2"/>
-              </a:rPr>
-              <a:t>Compose guide</a:t>
-            </a:r>
-            <a:r>
-              <a:rPr sz="2100" b="0" i="0">
-                <a:solidFill>
-                  <a:srgbClr val="20344A"/>
-                </a:solidFill>
-                <a:latin typeface="Arial"/>
-              </a:rPr>
-              <a:t>; stop </a:t>
+              <a:t>ports first.</a:t>
             </a:r>
           </a:p>
         </p:txBody>
@@ -4831,14 +4763,14 @@
               </a:defRPr>
             </a:pPr>
             <a:r>
-              <a:t>SOURCE 10 / 18  ·  CONTINUED 2</a:t>
-            </a:r>
-          </a:p>
-        </p:txBody>
-      </p:sp>
-      <p:sp>
-        <p:nvSpPr>
-          <p:cNvPr id="4" name="title:line-88"/>
+              <a:t>SOURCE 11 / 18</a:t>
+            </a:r>
+          </a:p>
+        </p:txBody>
+      </p:sp>
+      <p:sp>
+        <p:nvSpPr>
+          <p:cNvPr id="4" name="title:line-97"/>
           <p:cNvSpPr txBox="1"/>
           <p:nvPr/>
         </p:nvSpPr>
@@ -4882,7 +4814,7 @@
                 </a:solidFill>
                 <a:latin typeface="Arial"/>
               </a:rPr>
-              <a:t>Show real startup and CSV results</a:t>
+              <a:t>Show validation and its test</a:t>
             </a:r>
           </a:p>
         </p:txBody>
@@ -4934,14 +4866,14 @@
       </p:sp>
       <p:sp>
         <p:nvSpPr>
-          <p:cNvPr id="6" name="content:line-93:2"/>
+          <p:cNvPr id="6" name="content:line-99:0"/>
           <p:cNvSpPr txBox="1"/>
           <p:nvPr/>
         </p:nvSpPr>
         <p:spPr>
           <a:xfrm>
             <a:off x="594360" y="1737360"/>
-            <a:ext cx="11003279" cy="428244"/>
+            <a:ext cx="11003279" cy="780288"/>
           </a:xfrm>
           <a:prstGeom prst="rect">
             <a:avLst/>
@@ -4970,16 +4902,212 @@
                 </a:solidFill>
                 <a:latin typeface="Arial"/>
               </a:defRPr>
-              <a:buChar char=" "/>
-            </a:pPr>
-            <a:r>
-              <a:rPr sz="2100" b="0" i="0">
-                <a:solidFill>
-                  <a:srgbClr val="20344A"/>
-                </a:solidFill>
-                <a:latin typeface="Arial"/>
-              </a:rPr>
-              <a:t>standalone servers using the same ports first.</a:t>
+              <a:buChar char="•"/>
+            </a:pPr>
+            <a:r>
+              <a:rPr sz="2100" b="0" i="0">
+                <a:solidFill>
+                  <a:srgbClr val="20344A"/>
+                </a:solidFill>
+                <a:latin typeface="Arial"/>
+              </a:rPr>
+              <a:t>Demonstrate one invalid input rejected clearly; it must not </a:t>
+            </a:r>
+            <a:br/>
+            <a:r>
+              <a:rPr sz="2100" b="0" i="0">
+                <a:solidFill>
+                  <a:srgbClr val="20344A"/>
+                </a:solidFill>
+                <a:latin typeface="Arial"/>
+              </a:rPr>
+              <a:t>appear as a successful result.</a:t>
+            </a:r>
+          </a:p>
+        </p:txBody>
+      </p:sp>
+      <p:sp>
+        <p:nvSpPr>
+          <p:cNvPr id="7" name="content:line-100:0"/>
+          <p:cNvSpPr txBox="1"/>
+          <p:nvPr/>
+        </p:nvSpPr>
+        <p:spPr>
+          <a:xfrm>
+            <a:off x="594360" y="2581656"/>
+            <a:ext cx="11003279" cy="780288"/>
+          </a:xfrm>
+          <a:prstGeom prst="rect">
+            <a:avLst/>
+          </a:prstGeom>
+          <a:noFill/>
+        </p:spPr>
+        <p:txBody>
+          <a:bodyPr wrap="none" anchor="t" lIns="88900" rIns="88900" tIns="38100" bIns="38100">
+            <a:noAutofit/>
+          </a:bodyPr>
+          <a:lstStyle/>
+          <a:p>
+            <a:pPr marL="279400" indent="-215900">
+              <a:lnSpc>
+                <a:spcPts val="2772"/>
+              </a:lnSpc>
+              <a:spcBef>
+                <a:spcPts val="0"/>
+              </a:spcBef>
+              <a:spcAft>
+                <a:spcPts val="0"/>
+              </a:spcAft>
+              <a:defRPr sz="2100">
+                <a:solidFill>
+                  <a:srgbClr val="20344A"/>
+                </a:solidFill>
+                <a:latin typeface="Arial"/>
+              </a:defRPr>
+              <a:buChar char="•"/>
+            </a:pPr>
+            <a:r>
+              <a:rPr sz="2100" b="0" i="0">
+                <a:solidFill>
+                  <a:srgbClr val="20344A"/>
+                </a:solidFill>
+                <a:latin typeface="Arial"/>
+              </a:rPr>
+              <a:t>Explain the rule: expected types, allowed bounds, or </a:t>
+            </a:r>
+            <a:br/>
+            <a:r>
+              <a:rPr sz="2100" b="0" i="0">
+                <a:solidFill>
+                  <a:srgbClr val="20344A"/>
+                </a:solidFill>
+                <a:latin typeface="Arial"/>
+              </a:rPr>
+              <a:t>missing-value handling. Missing does not mean zero.</a:t>
+            </a:r>
+          </a:p>
+        </p:txBody>
+      </p:sp>
+      <p:sp>
+        <p:nvSpPr>
+          <p:cNvPr id="8" name="content:line-101:0"/>
+          <p:cNvSpPr txBox="1"/>
+          <p:nvPr/>
+        </p:nvSpPr>
+        <p:spPr>
+          <a:xfrm>
+            <a:off x="594360" y="3425952"/>
+            <a:ext cx="11003279" cy="780288"/>
+          </a:xfrm>
+          <a:prstGeom prst="rect">
+            <a:avLst/>
+          </a:prstGeom>
+          <a:noFill/>
+        </p:spPr>
+        <p:txBody>
+          <a:bodyPr wrap="none" anchor="t" lIns="88900" rIns="88900" tIns="38100" bIns="38100">
+            <a:noAutofit/>
+          </a:bodyPr>
+          <a:lstStyle/>
+          <a:p>
+            <a:pPr marL="279400" indent="-215900">
+              <a:lnSpc>
+                <a:spcPts val="2772"/>
+              </a:lnSpc>
+              <a:spcBef>
+                <a:spcPts val="0"/>
+              </a:spcBef>
+              <a:spcAft>
+                <a:spcPts val="0"/>
+              </a:spcAft>
+              <a:defRPr sz="2100">
+                <a:solidFill>
+                  <a:srgbClr val="20344A"/>
+                </a:solidFill>
+                <a:latin typeface="Arial"/>
+              </a:defRPr>
+              <a:buChar char="•"/>
+            </a:pPr>
+            <a:r>
+              <a:rPr sz="2100" b="0" i="0">
+                <a:solidFill>
+                  <a:srgbClr val="20344A"/>
+                </a:solidFill>
+                <a:latin typeface="Arial"/>
+              </a:rPr>
+              <a:t>Show the API error for the rejected input and open its </a:t>
+            </a:r>
+            <a:br/>
+            <a:r>
+              <a:rPr sz="2100" b="0" i="0">
+                <a:solidFill>
+                  <a:srgbClr val="20344A"/>
+                </a:solidFill>
+                <a:latin typeface="Arial"/>
+              </a:rPr>
+              <a:t>corresponding passing validation test.</a:t>
+            </a:r>
+          </a:p>
+        </p:txBody>
+      </p:sp>
+      <p:sp>
+        <p:nvSpPr>
+          <p:cNvPr id="9" name="content:line-102:0"/>
+          <p:cNvSpPr txBox="1"/>
+          <p:nvPr/>
+        </p:nvSpPr>
+        <p:spPr>
+          <a:xfrm>
+            <a:off x="594360" y="4270248"/>
+            <a:ext cx="11003279" cy="780288"/>
+          </a:xfrm>
+          <a:prstGeom prst="rect">
+            <a:avLst/>
+          </a:prstGeom>
+          <a:noFill/>
+        </p:spPr>
+        <p:txBody>
+          <a:bodyPr wrap="none" anchor="t" lIns="88900" rIns="88900" tIns="38100" bIns="38100">
+            <a:noAutofit/>
+          </a:bodyPr>
+          <a:lstStyle/>
+          <a:p>
+            <a:pPr marL="279400" indent="-215900">
+              <a:lnSpc>
+                <a:spcPts val="2772"/>
+              </a:lnSpc>
+              <a:spcBef>
+                <a:spcPts val="0"/>
+              </a:spcBef>
+              <a:spcAft>
+                <a:spcPts val="0"/>
+              </a:spcAft>
+              <a:defRPr sz="2100">
+                <a:solidFill>
+                  <a:srgbClr val="20344A"/>
+                </a:solidFill>
+                <a:latin typeface="Arial"/>
+              </a:defRPr>
+              <a:buChar char="•"/>
+            </a:pPr>
+            <a:r>
+              <a:rPr sz="2100" b="0" i="0">
+                <a:solidFill>
+                  <a:srgbClr val="20344A"/>
+                </a:solidFill>
+                <a:latin typeface="Arial"/>
+              </a:rPr>
+              <a:t>Instructor checks the observed rejection against the group's </a:t>
+            </a:r>
+            <a:br/>
+            <a:r>
+              <a:rPr sz="2100" b="0" i="0">
+                <a:solidFill>
+                  <a:srgbClr val="20344A"/>
+                </a:solidFill>
+                <a:latin typeface="Arial"/>
+              </a:rPr>
+              <a:t>declared rule.</a:t>
             </a:r>
           </a:p>
         </p:txBody>
@@ -5093,14 +5221,14 @@
               </a:defRPr>
             </a:pPr>
             <a:r>
-              <a:t>SOURCE 11 / 18</a:t>
-            </a:r>
-          </a:p>
-        </p:txBody>
-      </p:sp>
-      <p:sp>
-        <p:nvSpPr>
-          <p:cNvPr id="4" name="title:line-97"/>
+              <a:t>SOURCE 12 / 18</a:t>
+            </a:r>
+          </a:p>
+        </p:txBody>
+      </p:sp>
+      <p:sp>
+        <p:nvSpPr>
+          <p:cNvPr id="4" name="title:line-106"/>
           <p:cNvSpPr txBox="1"/>
           <p:nvPr/>
         </p:nvSpPr>
@@ -5144,7 +5272,7 @@
                 </a:solidFill>
                 <a:latin typeface="Arial"/>
               </a:rPr>
-              <a:t>Show validation and its test</a:t>
+              <a:t>Inspect local tests and hosted CI</a:t>
             </a:r>
           </a:p>
         </p:txBody>
@@ -5196,7 +5324,7 @@
       </p:sp>
       <p:sp>
         <p:nvSpPr>
-          <p:cNvPr id="6" name="content:line-99:0"/>
+          <p:cNvPr id="6" name="content:line-108:0"/>
           <p:cNvSpPr txBox="1"/>
           <p:nvPr/>
         </p:nvSpPr>
@@ -5241,7 +5369,25 @@
                 </a:solidFill>
                 <a:latin typeface="Arial"/>
               </a:rPr>
-              <a:t>Demonstrate one invalid input rejected clearly; it must not </a:t>
+              <a:t>In the active local environment, run </a:t>
+            </a:r>
+            <a:r>
+              <a:rPr sz="2100" b="0" i="0">
+                <a:solidFill>
+                  <a:srgbClr val="20344A"/>
+                </a:solidFill>
+                <a:latin typeface="Courier New"/>
+              </a:rPr>
+              <a:t>pytest</a:t>
+            </a:r>
+            <a:r>
+              <a:rPr sz="2100" b="0" i="0">
+                <a:solidFill>
+                  <a:srgbClr val="20344A"/>
+                </a:solidFill>
+                <a:latin typeface="Arial"/>
+              </a:rPr>
+              <a:t>; show passing </a:t>
             </a:r>
             <a:br/>
             <a:r>
@@ -5251,20 +5397,92 @@
                 </a:solidFill>
                 <a:latin typeface="Arial"/>
               </a:rPr>
-              <a:t>appear as a successful result.</a:t>
-            </a:r>
-          </a:p>
-        </p:txBody>
-      </p:sp>
-      <p:sp>
-        <p:nvSpPr>
-          <p:cNvPr id="7" name="content:line-100:0"/>
+              <a:t>output.</a:t>
+            </a:r>
+          </a:p>
+        </p:txBody>
+      </p:sp>
+      <p:sp>
+        <p:nvSpPr>
+          <p:cNvPr id="7" name="content:line-109:0"/>
           <p:cNvSpPr txBox="1"/>
           <p:nvPr/>
         </p:nvSpPr>
         <p:spPr>
           <a:xfrm>
             <a:off x="594360" y="2581656"/>
+            <a:ext cx="11003279" cy="1132332"/>
+          </a:xfrm>
+          <a:prstGeom prst="rect">
+            <a:avLst/>
+          </a:prstGeom>
+          <a:noFill/>
+        </p:spPr>
+        <p:txBody>
+          <a:bodyPr wrap="none" anchor="t" lIns="88900" rIns="88900" tIns="38100" bIns="38100">
+            <a:noAutofit/>
+          </a:bodyPr>
+          <a:lstStyle/>
+          <a:p>
+            <a:pPr marL="279400" indent="-215900">
+              <a:lnSpc>
+                <a:spcPts val="2772"/>
+              </a:lnSpc>
+              <a:spcBef>
+                <a:spcPts val="0"/>
+              </a:spcBef>
+              <a:spcAft>
+                <a:spcPts val="0"/>
+              </a:spcAft>
+              <a:defRPr sz="2100">
+                <a:solidFill>
+                  <a:srgbClr val="20344A"/>
+                </a:solidFill>
+                <a:latin typeface="Arial"/>
+              </a:defRPr>
+              <a:buChar char="•"/>
+            </a:pPr>
+            <a:r>
+              <a:rPr sz="2100" b="0" i="0">
+                <a:solidFill>
+                  <a:srgbClr val="20344A"/>
+                </a:solidFill>
+                <a:latin typeface="Arial"/>
+              </a:rPr>
+              <a:t>Open a successful GitHub Actions run for the demonstrated </a:t>
+            </a:r>
+            <a:br/>
+            <a:r>
+              <a:rPr sz="2100" b="0" i="0">
+                <a:solidFill>
+                  <a:srgbClr val="20344A"/>
+                </a:solidFill>
+                <a:latin typeface="Arial"/>
+              </a:rPr>
+              <a:t>commit with the test job switched on. CI means automated </a:t>
+            </a:r>
+            <a:br/>
+            <a:r>
+              <a:rPr sz="2100" b="0" i="0">
+                <a:solidFill>
+                  <a:srgbClr val="20344A"/>
+                </a:solidFill>
+                <a:latin typeface="Arial"/>
+              </a:rPr>
+              <a:t>checks on GitHub; a local pass alone is insufficient.</a:t>
+            </a:r>
+          </a:p>
+        </p:txBody>
+      </p:sp>
+      <p:sp>
+        <p:nvSpPr>
+          <p:cNvPr id="8" name="content:line-110:0"/>
+          <p:cNvSpPr txBox="1"/>
+          <p:nvPr/>
+        </p:nvSpPr>
+        <p:spPr>
+          <a:xfrm>
+            <a:off x="594360" y="3777996"/>
             <a:ext cx="11003279" cy="780288"/>
           </a:xfrm>
           <a:prstGeom prst="rect">
@@ -5303,7 +5521,7 @@
                 </a:solidFill>
                 <a:latin typeface="Arial"/>
               </a:rPr>
-              <a:t>Explain the rule: expected types, allowed bounds, or </a:t>
+              <a:t>Instructor opens tests for processing, invalid inputs, and </a:t>
             </a:r>
             <a:br/>
             <a:r>
@@ -5313,21 +5531,21 @@
                 </a:solidFill>
                 <a:latin typeface="Arial"/>
               </a:rPr>
-              <a:t>missing-value handling. Missing does not mean zero.</a:t>
-            </a:r>
-          </a:p>
-        </p:txBody>
-      </p:sp>
-      <p:sp>
-        <p:nvSpPr>
-          <p:cNvPr id="8" name="content:line-101:0"/>
-          <p:cNvSpPr txBox="1"/>
-          <p:nvPr/>
-        </p:nvSpPr>
-        <p:spPr>
-          <a:xfrm>
-            <a:off x="594360" y="3425952"/>
-            <a:ext cx="11003279" cy="780288"/>
+              <a:t>agreement rules.</a:t>
+            </a:r>
+          </a:p>
+        </p:txBody>
+      </p:sp>
+      <p:sp>
+        <p:nvSpPr>
+          <p:cNvPr id="9" name="content:line-111:0"/>
+          <p:cNvSpPr txBox="1"/>
+          <p:nvPr/>
+        </p:nvSpPr>
+        <p:spPr>
+          <a:xfrm>
+            <a:off x="594360" y="4622292"/>
+            <a:ext cx="11003279" cy="1132332"/>
           </a:xfrm>
           <a:prstGeom prst="rect">
             <a:avLst/>
@@ -5365,7 +5583,7 @@
                 </a:solidFill>
                 <a:latin typeface="Arial"/>
               </a:rPr>
-              <a:t>In the supplied example, show the API error and open its </a:t>
+              <a:t>Tests check declared behavior, not scientific validity. A </a:t>
             </a:r>
             <a:br/>
             <a:r>
@@ -5375,89 +5593,17 @@
                 </a:solidFill>
                 <a:latin typeface="Arial"/>
               </a:rPr>
-              <a:t>corresponding passing validation test.</a:t>
-            </a:r>
-          </a:p>
-        </p:txBody>
-      </p:sp>
-      <p:sp>
-        <p:nvSpPr>
-          <p:cNvPr id="9" name="content:line-102:0"/>
-          <p:cNvSpPr txBox="1"/>
-          <p:nvPr/>
-        </p:nvSpPr>
-        <p:spPr>
-          <a:xfrm>
-            <a:off x="594360" y="4270248"/>
-            <a:ext cx="11003279" cy="780288"/>
-          </a:xfrm>
-          <a:prstGeom prst="rect">
-            <a:avLst/>
-          </a:prstGeom>
-          <a:noFill/>
-        </p:spPr>
-        <p:txBody>
-          <a:bodyPr wrap="none" anchor="t" lIns="88900" rIns="88900" tIns="38100" bIns="38100">
-            <a:noAutofit/>
-          </a:bodyPr>
-          <a:lstStyle/>
-          <a:p>
-            <a:pPr marL="279400" indent="-215900">
-              <a:lnSpc>
-                <a:spcPts val="2772"/>
-              </a:lnSpc>
-              <a:spcBef>
-                <a:spcPts val="0"/>
-              </a:spcBef>
-              <a:spcAft>
-                <a:spcPts val="0"/>
-              </a:spcAft>
-              <a:defRPr sz="2100">
-                <a:solidFill>
-                  <a:srgbClr val="20344A"/>
-                </a:solidFill>
-                <a:latin typeface="Arial"/>
-              </a:defRPr>
-              <a:buChar char="•"/>
-            </a:pPr>
-            <a:r>
-              <a:rPr sz="2100" b="0" i="0">
-                <a:solidFill>
-                  <a:srgbClr val="20344A"/>
-                </a:solidFill>
-                <a:latin typeface="Arial"/>
-              </a:rPr>
-              <a:t>Instructor checks the observed rejection against the </a:t>
-            </a:r>
-            <a:r>
-              <a:rPr sz="2100" b="0" i="0">
-                <a:solidFill>
-                  <a:srgbClr val="007F82"/>
-                </a:solidFill>
-                <a:latin typeface="Arial"/>
-                <a:hlinkClick r:id="rId2"/>
-              </a:rPr>
-              <a:t>API </a:t>
+              <a:t>workflow reporting success does not itself configure required </a:t>
             </a:r>
             <a:br/>
             <a:r>
               <a:rPr sz="2100" b="0" i="0">
                 <a:solidFill>
-                  <a:srgbClr val="007F82"/>
-                </a:solidFill>
-                <a:latin typeface="Arial"/>
-                <a:hlinkClick r:id="rId2"/>
-              </a:rPr>
-              <a:t>contract</a:t>
-            </a:r>
-            <a:r>
-              <a:rPr sz="2100" b="0" i="0">
-                <a:solidFill>
-                  <a:srgbClr val="20344A"/>
-                </a:solidFill>
-                <a:latin typeface="Arial"/>
-              </a:rPr>
-              <a:t> and the group's declared rule.</a:t>
+                  <a:srgbClr val="20344A"/>
+                </a:solidFill>
+                <a:latin typeface="Arial"/>
+              </a:rPr>
+              <a:t>checks.</a:t>
             </a:r>
           </a:p>
         </p:txBody>
@@ -5571,14 +5717,14 @@
               </a:defRPr>
             </a:pPr>
             <a:r>
-              <a:t>SOURCE 12 / 18</a:t>
-            </a:r>
-          </a:p>
-        </p:txBody>
-      </p:sp>
-      <p:sp>
-        <p:nvSpPr>
-          <p:cNvPr id="4" name="title:line-106"/>
+              <a:t>SOURCE 13 / 18</a:t>
+            </a:r>
+          </a:p>
+        </p:txBody>
+      </p:sp>
+      <p:sp>
+        <p:nvSpPr>
+          <p:cNvPr id="4" name="title:line-115"/>
           <p:cNvSpPr txBox="1"/>
           <p:nvPr/>
         </p:nvSpPr>
@@ -5622,7 +5768,7 @@
                 </a:solidFill>
                 <a:latin typeface="Arial"/>
               </a:rPr>
-              <a:t>Inspect local tests and hosted CI</a:t>
+              <a:t>Demonstrate the two practical Rs</a:t>
             </a:r>
           </a:p>
         </p:txBody>
@@ -5674,7 +5820,7 @@
       </p:sp>
       <p:sp>
         <p:nvSpPr>
-          <p:cNvPr id="6" name="content:line-108:0"/>
+          <p:cNvPr id="6" name="content:line-117:0"/>
           <p:cNvSpPr txBox="1"/>
           <p:nvPr/>
         </p:nvSpPr>
@@ -5719,16 +5865,7 @@
                 </a:solidFill>
                 <a:latin typeface="Arial"/>
               </a:rPr>
-              <a:t>In the active local environment, run </a:t>
-            </a:r>
-            <a:r>
-              <a:rPr sz="2100" b="0" i="0">
-                <a:solidFill>
-                  <a:srgbClr val="20344A"/>
-                </a:solidFill>
-                <a:latin typeface="Courier New"/>
-              </a:rPr>
-              <a:t>python -m pytest </a:t>
+              <a:t>Repeatability: agreement under the same conditions. Compare </a:t>
             </a:r>
             <a:br/>
             <a:r>
@@ -5736,25 +5873,16 @@
                 <a:solidFill>
                   <a:srgbClr val="20344A"/>
                 </a:solidFill>
-                <a:latin typeface="Courier New"/>
-              </a:rPr>
-              <a:t>backend/tests</a:t>
-            </a:r>
-            <a:r>
-              <a:rPr sz="2100" b="0" i="0">
-                <a:solidFill>
-                  <a:srgbClr val="20344A"/>
-                </a:solidFill>
-                <a:latin typeface="Arial"/>
-              </a:rPr>
-              <a:t>; show passing output.</a:t>
-            </a:r>
-          </a:p>
-        </p:txBody>
-      </p:sp>
-      <p:sp>
-        <p:nvSpPr>
-          <p:cNvPr id="7" name="content:line-109:0"/>
+                <a:latin typeface="Arial"/>
+              </a:rPr>
+              <a:t>local run 1 with local run 2.</a:t>
+            </a:r>
+          </a:p>
+        </p:txBody>
+      </p:sp>
+      <p:sp>
+        <p:nvSpPr>
+          <p:cNvPr id="7" name="content:line-118:0"/>
           <p:cNvSpPr txBox="1"/>
           <p:nvPr/>
         </p:nvSpPr>
@@ -5799,7 +5927,7 @@
                 </a:solidFill>
                 <a:latin typeface="Arial"/>
               </a:rPr>
-              <a:t>Open a successful GitHub Actions run for the demonstrated </a:t>
+              <a:t>Replicability: agreement under slightly different conditions. </a:t>
             </a:r>
             <a:br/>
             <a:r>
@@ -5809,7 +5937,7 @@
                 </a:solidFill>
                 <a:latin typeface="Arial"/>
               </a:rPr>
-              <a:t>commit. CI means automated checks on GitHub; a local pass </a:t>
+              <a:t>Compare a Release installed in a fresh environment, and a real </a:t>
             </a:r>
             <a:br/>
             <a:r>
@@ -5819,20 +5947,82 @@
                 </a:solidFill>
                 <a:latin typeface="Arial"/>
               </a:rPr>
-              <a:t>alone is insufficient.</a:t>
-            </a:r>
-          </a:p>
-        </p:txBody>
-      </p:sp>
-      <p:sp>
-        <p:nvSpPr>
-          <p:cNvPr id="8" name="content:line-110:0"/>
+              <a:t>Docker run, with the local run.</a:t>
+            </a:r>
+          </a:p>
+        </p:txBody>
+      </p:sp>
+      <p:sp>
+        <p:nvSpPr>
+          <p:cNvPr id="8" name="content:line-119:0"/>
           <p:cNvSpPr txBox="1"/>
           <p:nvPr/>
         </p:nvSpPr>
         <p:spPr>
           <a:xfrm>
             <a:off x="594360" y="3777996"/>
+            <a:ext cx="11003279" cy="780288"/>
+          </a:xfrm>
+          <a:prstGeom prst="rect">
+            <a:avLst/>
+          </a:prstGeom>
+          <a:noFill/>
+        </p:spPr>
+        <p:txBody>
+          <a:bodyPr wrap="none" anchor="t" lIns="88900" rIns="88900" tIns="38100" bIns="38100">
+            <a:noAutofit/>
+          </a:bodyPr>
+          <a:lstStyle/>
+          <a:p>
+            <a:pPr marL="279400" indent="-215900">
+              <a:lnSpc>
+                <a:spcPts val="2772"/>
+              </a:lnSpc>
+              <a:spcBef>
+                <a:spcPts val="0"/>
+              </a:spcBef>
+              <a:spcAft>
+                <a:spcPts val="0"/>
+              </a:spcAft>
+              <a:defRPr sz="2100">
+                <a:solidFill>
+                  <a:srgbClr val="20344A"/>
+                </a:solidFill>
+                <a:latin typeface="Arial"/>
+              </a:defRPr>
+              <a:buChar char="•"/>
+            </a:pPr>
+            <a:r>
+              <a:rPr sz="2100" b="0" i="0">
+                <a:solidFill>
+                  <a:srgbClr val="20344A"/>
+                </a:solidFill>
+                <a:latin typeface="Arial"/>
+              </a:rPr>
+              <a:t>Keep code and CSV unchanged; show successful comparisons, </a:t>
+            </a:r>
+            <a:br/>
+            <a:r>
+              <a:rPr sz="2100" b="0" i="0">
+                <a:solidFill>
+                  <a:srgbClr val="20344A"/>
+                </a:solidFill>
+                <a:latin typeface="Arial"/>
+              </a:rPr>
+              <a:t>underlying captures, commands, logs, and environment details.</a:t>
+            </a:r>
+          </a:p>
+        </p:txBody>
+      </p:sp>
+      <p:sp>
+        <p:nvSpPr>
+          <p:cNvPr id="9" name="content:line-120:0"/>
+          <p:cNvSpPr txBox="1"/>
+          <p:nvPr/>
+        </p:nvSpPr>
+        <p:spPr>
+          <a:xfrm>
+            <a:off x="594360" y="4622292"/>
             <a:ext cx="11003279" cy="1132332"/>
           </a:xfrm>
           <a:prstGeom prst="rect">
@@ -5871,7 +6061,7 @@
                 </a:solidFill>
                 <a:latin typeface="Arial"/>
               </a:rPr>
-              <a:t>Instructor opens tests at public processing, API, and </a:t>
+              <a:t>Reproducibility means agreement under very different </a:t>
             </a:r>
             <a:br/>
             <a:r>
@@ -5881,7 +6071,7 @@
                 </a:solidFill>
                 <a:latin typeface="Arial"/>
               </a:rPr>
-              <a:t>comparison boundaries: expected outputs, invalid inputs, and </a:t>
+              <a:t>conditions in this course; independent simulation, cross-group </a:t>
             </a:r>
             <a:br/>
             <a:r>
@@ -5891,21 +6081,21 @@
                 </a:solidFill>
                 <a:latin typeface="Arial"/>
               </a:rPr>
-              <a:t>agreement rules.</a:t>
-            </a:r>
-          </a:p>
-        </p:txBody>
-      </p:sp>
-      <p:sp>
-        <p:nvSpPr>
-          <p:cNvPr id="9" name="content:line-111:0"/>
-          <p:cNvSpPr txBox="1"/>
-          <p:nvPr/>
-        </p:nvSpPr>
-        <p:spPr>
-          <a:xfrm>
-            <a:off x="594360" y="4974336"/>
-            <a:ext cx="11003279" cy="1132332"/>
+              <a:t>reproduction, and new-data experiments are not required.</a:t>
+            </a:r>
+          </a:p>
+        </p:txBody>
+      </p:sp>
+      <p:sp>
+        <p:nvSpPr>
+          <p:cNvPr id="10" name="content:line-121:0"/>
+          <p:cNvSpPr txBox="1"/>
+          <p:nvPr/>
+        </p:nvSpPr>
+        <p:spPr>
+          <a:xfrm>
+            <a:off x="594360" y="5818632"/>
+            <a:ext cx="11003279" cy="428244"/>
           </a:xfrm>
           <a:prstGeom prst="rect">
             <a:avLst/>
@@ -5943,27 +6133,7 @@
                 </a:solidFill>
                 <a:latin typeface="Arial"/>
               </a:rPr>
-              <a:t>Tests check declared behavior, not scientific validity. A </a:t>
-            </a:r>
-            <a:br/>
-            <a:r>
-              <a:rPr sz="2100" b="0" i="0">
-                <a:solidFill>
-                  <a:srgbClr val="20344A"/>
-                </a:solidFill>
-                <a:latin typeface="Arial"/>
-              </a:rPr>
-              <a:t>workflow reporting success does not itself configure required </a:t>
-            </a:r>
-            <a:br/>
-            <a:r>
-              <a:rPr sz="2100" b="0" i="0">
-                <a:solidFill>
-                  <a:srgbClr val="20344A"/>
-                </a:solidFill>
-                <a:latin typeface="Arial"/>
-              </a:rPr>
-              <a:t>checks; see </a:t>
+              <a:t>Use the </a:t>
             </a:r>
             <a:r>
               <a:rPr sz="2100" b="0" i="0">
@@ -5973,26 +6143,7 @@
                 <a:latin typeface="Arial"/>
                 <a:hlinkClick r:id="rId2"/>
               </a:rPr>
-              <a:t>testing</a:t>
-            </a:r>
-            <a:r>
-              <a:rPr sz="2100" b="0" i="0">
-                <a:solidFill>
-                  <a:srgbClr val="20344A"/>
-                </a:solidFill>
-                <a:latin typeface="Arial"/>
-              </a:rPr>
-              <a:t> and </a:t>
-            </a:r>
-            <a:r>
-              <a:rPr sz="2100" b="0" i="0">
-                <a:solidFill>
-                  <a:srgbClr val="007F82"/>
-                </a:solidFill>
-                <a:latin typeface="Arial"/>
-                <a:hlinkClick r:id="rId3"/>
-              </a:rPr>
-              <a:t>CI</a:t>
+              <a:t>glossary</a:t>
             </a:r>
             <a:r>
               <a:rPr sz="2100" b="0" i="0">
@@ -6115,14 +6266,14 @@
               </a:defRPr>
             </a:pPr>
             <a:r>
-              <a:t>SOURCE 13 / 18</a:t>
-            </a:r>
-          </a:p>
-        </p:txBody>
-      </p:sp>
-      <p:sp>
-        <p:nvSpPr>
-          <p:cNvPr id="4" name="title:line-115"/>
+              <a:t>SOURCE 14 / 18</a:t>
+            </a:r>
+          </a:p>
+        </p:txBody>
+      </p:sp>
+      <p:sp>
+        <p:nvSpPr>
+          <p:cNvPr id="4" name="title:line-125"/>
           <p:cNvSpPr txBox="1"/>
           <p:nvPr/>
         </p:nvSpPr>
@@ -6166,7 +6317,7 @@
                 </a:solidFill>
                 <a:latin typeface="Arial"/>
               </a:rPr>
-              <a:t>Demonstrate the two practical Rs</a:t>
+              <a:t>Inspect agreement, field by field</a:t>
             </a:r>
           </a:p>
         </p:txBody>
@@ -6218,13 +6369,85 @@
       </p:sp>
       <p:sp>
         <p:nvSpPr>
-          <p:cNvPr id="6" name="content:line-117:0"/>
+          <p:cNvPr id="6" name="content:line-127:0"/>
           <p:cNvSpPr txBox="1"/>
           <p:nvPr/>
         </p:nvSpPr>
         <p:spPr>
           <a:xfrm>
             <a:off x="594360" y="1737360"/>
+            <a:ext cx="11003279" cy="1132332"/>
+          </a:xfrm>
+          <a:prstGeom prst="rect">
+            <a:avLst/>
+          </a:prstGeom>
+          <a:noFill/>
+        </p:spPr>
+        <p:txBody>
+          <a:bodyPr wrap="none" anchor="t" lIns="88900" rIns="88900" tIns="38100" bIns="38100">
+            <a:noAutofit/>
+          </a:bodyPr>
+          <a:lstStyle/>
+          <a:p>
+            <a:pPr marL="279400" indent="-215900">
+              <a:lnSpc>
+                <a:spcPts val="2772"/>
+              </a:lnSpc>
+              <a:spcBef>
+                <a:spcPts val="0"/>
+              </a:spcBef>
+              <a:spcAft>
+                <a:spcPts val="0"/>
+              </a:spcAft>
+              <a:defRPr sz="2100">
+                <a:solidFill>
+                  <a:srgbClr val="20344A"/>
+                </a:solidFill>
+                <a:latin typeface="Arial"/>
+              </a:defRPr>
+              <a:buChar char="•"/>
+            </a:pPr>
+            <a:r>
+              <a:rPr sz="2100" b="0" i="0">
+                <a:solidFill>
+                  <a:srgbClr val="20344A"/>
+                </a:solidFill>
+                <a:latin typeface="Arial"/>
+              </a:rPr>
+              <a:t>Exact: cleaned records, identifiers, dates, counts, types, </a:t>
+            </a:r>
+            <a:br/>
+            <a:r>
+              <a:rPr sz="2100" b="0" i="0">
+                <a:solidFill>
+                  <a:srgbClr val="20344A"/>
+                </a:solidFill>
+                <a:latin typeface="Arial"/>
+              </a:rPr>
+              <a:t>structure, ordering, and nulls. Missing stays distinct from </a:t>
+            </a:r>
+            <a:br/>
+            <a:r>
+              <a:rPr sz="2100" b="0" i="0">
+                <a:solidFill>
+                  <a:srgbClr val="20344A"/>
+                </a:solidFill>
+                <a:latin typeface="Arial"/>
+              </a:rPr>
+              <a:t>zero.</a:t>
+            </a:r>
+          </a:p>
+        </p:txBody>
+      </p:sp>
+      <p:sp>
+        <p:nvSpPr>
+          <p:cNvPr id="7" name="content:line-128:0"/>
+          <p:cNvSpPr txBox="1"/>
+          <p:nvPr/>
+        </p:nvSpPr>
+        <p:spPr>
+          <a:xfrm>
+            <a:off x="594360" y="2933700"/>
             <a:ext cx="11003279" cy="780288"/>
           </a:xfrm>
           <a:prstGeom prst="rect">
@@ -6263,7 +6486,7 @@
                 </a:solidFill>
                 <a:latin typeface="Arial"/>
               </a:rPr>
-              <a:t>Repeatability: agreement under the same conditions. Compare </a:t>
+              <a:t>Only derived decimals receive declared tolerances documented </a:t>
             </a:r>
             <a:br/>
             <a:r>
@@ -6273,21 +6496,74 @@
                 </a:solidFill>
                 <a:latin typeface="Arial"/>
               </a:rPr>
-              <a:t>local run 1 with local run 2.</a:t>
-            </a:r>
-          </a:p>
-        </p:txBody>
-      </p:sp>
-      <p:sp>
-        <p:nvSpPr>
-          <p:cNvPr id="7" name="content:line-118:0"/>
-          <p:cNvSpPr txBox="1"/>
-          <p:nvPr/>
-        </p:nvSpPr>
-        <p:spPr>
-          <a:xfrm>
-            <a:off x="594360" y="2581656"/>
-            <a:ext cx="11003279" cy="780288"/>
+              <a:t>in tests.</a:t>
+            </a:r>
+          </a:p>
+        </p:txBody>
+      </p:sp>
+      <p:sp>
+        <p:nvSpPr>
+          <p:cNvPr id="8" name="content:line-131:0"/>
+          <p:cNvSpPr txBox="1"/>
+          <p:nvPr/>
+        </p:nvSpPr>
+        <p:spPr>
+          <a:xfrm>
+            <a:off x="594360" y="3777996"/>
+            <a:ext cx="11003279" cy="377952"/>
+          </a:xfrm>
+          <a:prstGeom prst="rect">
+            <a:avLst/>
+          </a:prstGeom>
+          <a:solidFill>
+            <a:srgbClr val="EDF3F6"/>
+          </a:solidFill>
+        </p:spPr>
+        <p:txBody>
+          <a:bodyPr wrap="none" anchor="t" lIns="88900" rIns="88900" tIns="38100" bIns="38100">
+            <a:noAutofit/>
+          </a:bodyPr>
+          <a:lstStyle/>
+          <a:p>
+            <a:pPr>
+              <a:lnSpc>
+                <a:spcPts val="2376"/>
+              </a:lnSpc>
+              <a:spcBef>
+                <a:spcPts val="0"/>
+              </a:spcBef>
+              <a:spcAft>
+                <a:spcPts val="0"/>
+              </a:spcAft>
+              <a:defRPr sz="1800">
+                <a:solidFill>
+                  <a:srgbClr val="20344A"/>
+                </a:solidFill>
+                <a:latin typeface="Arial"/>
+              </a:defRPr>
+            </a:pPr>
+            <a:r>
+              <a:rPr sz="1800" b="0" i="0">
+                <a:solidFill>
+                  <a:srgbClr val="20344A"/>
+                </a:solidFill>
+                <a:latin typeface="Courier New"/>
+              </a:rPr>
+              <a:t>abs(actual - expected) &lt;= max(1e-9, 1e-9 * abs(expected))</a:t>
+            </a:r>
+          </a:p>
+        </p:txBody>
+      </p:sp>
+      <p:sp>
+        <p:nvSpPr>
+          <p:cNvPr id="9" name="content:line-134:0"/>
+          <p:cNvSpPr txBox="1"/>
+          <p:nvPr/>
+        </p:nvSpPr>
+        <p:spPr>
+          <a:xfrm>
+            <a:off x="594360" y="4155948"/>
+            <a:ext cx="11003279" cy="1484376"/>
           </a:xfrm>
           <a:prstGeom prst="rect">
             <a:avLst/>
@@ -6325,7 +6601,7 @@
                 </a:solidFill>
                 <a:latin typeface="Arial"/>
               </a:rPr>
-              <a:t>Replicability: agreement under slightly different conditions. </a:t>
+              <a:t>The first output is the reference. Instructor opens outputs </a:t>
             </a:r>
             <a:br/>
             <a:r>
@@ -6335,59 +6611,7 @@
                 </a:solidFill>
                 <a:latin typeface="Arial"/>
               </a:rPr>
-              <a:t>Compare local with real Docker execution of the same process.</a:t>
-            </a:r>
-          </a:p>
-        </p:txBody>
-      </p:sp>
-      <p:sp>
-        <p:nvSpPr>
-          <p:cNvPr id="8" name="content:line-119:0"/>
-          <p:cNvSpPr txBox="1"/>
-          <p:nvPr/>
-        </p:nvSpPr>
-        <p:spPr>
-          <a:xfrm>
-            <a:off x="594360" y="3425952"/>
-            <a:ext cx="11003279" cy="1132332"/>
-          </a:xfrm>
-          <a:prstGeom prst="rect">
-            <a:avLst/>
-          </a:prstGeom>
-          <a:noFill/>
-        </p:spPr>
-        <p:txBody>
-          <a:bodyPr wrap="none" anchor="t" lIns="88900" rIns="88900" tIns="38100" bIns="38100">
-            <a:noAutofit/>
-          </a:bodyPr>
-          <a:lstStyle/>
-          <a:p>
-            <a:pPr marL="279400" indent="-215900">
-              <a:lnSpc>
-                <a:spcPts val="2772"/>
-              </a:lnSpc>
-              <a:spcBef>
-                <a:spcPts val="0"/>
-              </a:spcBef>
-              <a:spcAft>
-                <a:spcPts val="0"/>
-              </a:spcAft>
-              <a:defRPr sz="2100">
-                <a:solidFill>
-                  <a:srgbClr val="20344A"/>
-                </a:solidFill>
-                <a:latin typeface="Arial"/>
-              </a:defRPr>
-              <a:buChar char="•"/>
-            </a:pPr>
-            <a:r>
-              <a:rPr sz="2100" b="0" i="0">
-                <a:solidFill>
-                  <a:srgbClr val="20344A"/>
-                </a:solidFill>
-                <a:latin typeface="Arial"/>
-              </a:rPr>
-              <a:t>Keep code and CSV bytes unchanged; show successful </a:t>
+              <a:t>and diagnostics; matching charts alone are insufficient. Do not </a:t>
             </a:r>
             <a:br/>
             <a:r>
@@ -6397,7 +6621,7 @@
                 </a:solidFill>
                 <a:latin typeface="Arial"/>
               </a:rPr>
-              <a:t>comparisons, underlying captures, commands, logs, </a:t>
+              <a:t>drop fields, round away differences, or widen tolerance to </a:t>
             </a:r>
             <a:br/>
             <a:r>
@@ -6407,169 +6631,7 @@
                 </a:solidFill>
                 <a:latin typeface="Arial"/>
               </a:rPr>
-              <a:t>environment details, and code/input identity.</a:t>
-            </a:r>
-          </a:p>
-        </p:txBody>
-      </p:sp>
-      <p:sp>
-        <p:nvSpPr>
-          <p:cNvPr id="9" name="content:line-120:0"/>
-          <p:cNvSpPr txBox="1"/>
-          <p:nvPr/>
-        </p:nvSpPr>
-        <p:spPr>
-          <a:xfrm>
-            <a:off x="594360" y="4622292"/>
-            <a:ext cx="11003279" cy="1132332"/>
-          </a:xfrm>
-          <a:prstGeom prst="rect">
-            <a:avLst/>
-          </a:prstGeom>
-          <a:noFill/>
-        </p:spPr>
-        <p:txBody>
-          <a:bodyPr wrap="none" anchor="t" lIns="88900" rIns="88900" tIns="38100" bIns="38100">
-            <a:noAutofit/>
-          </a:bodyPr>
-          <a:lstStyle/>
-          <a:p>
-            <a:pPr marL="279400" indent="-215900">
-              <a:lnSpc>
-                <a:spcPts val="2772"/>
-              </a:lnSpc>
-              <a:spcBef>
-                <a:spcPts val="0"/>
-              </a:spcBef>
-              <a:spcAft>
-                <a:spcPts val="0"/>
-              </a:spcAft>
-              <a:defRPr sz="2100">
-                <a:solidFill>
-                  <a:srgbClr val="20344A"/>
-                </a:solidFill>
-                <a:latin typeface="Arial"/>
-              </a:defRPr>
-              <a:buChar char="•"/>
-            </a:pPr>
-            <a:r>
-              <a:rPr sz="2100" b="0" i="0">
-                <a:solidFill>
-                  <a:srgbClr val="20344A"/>
-                </a:solidFill>
-                <a:latin typeface="Arial"/>
-              </a:rPr>
-              <a:t>Reproducibility means agreement under very different </a:t>
-            </a:r>
-            <a:br/>
-            <a:r>
-              <a:rPr sz="2100" b="0" i="0">
-                <a:solidFill>
-                  <a:srgbClr val="20344A"/>
-                </a:solidFill>
-                <a:latin typeface="Arial"/>
-              </a:rPr>
-              <a:t>conditions in this course; independent simulation, cross-group </a:t>
-            </a:r>
-            <a:br/>
-            <a:r>
-              <a:rPr sz="2100" b="0" i="0">
-                <a:solidFill>
-                  <a:srgbClr val="20344A"/>
-                </a:solidFill>
-                <a:latin typeface="Arial"/>
-              </a:rPr>
-              <a:t>reproduction, and new-data experiments are not required.</a:t>
-            </a:r>
-          </a:p>
-        </p:txBody>
-      </p:sp>
-      <p:sp>
-        <p:nvSpPr>
-          <p:cNvPr id="10" name="content:line-121:0"/>
-          <p:cNvSpPr txBox="1"/>
-          <p:nvPr/>
-        </p:nvSpPr>
-        <p:spPr>
-          <a:xfrm>
-            <a:off x="594360" y="5818632"/>
-            <a:ext cx="11003279" cy="428244"/>
-          </a:xfrm>
-          <a:prstGeom prst="rect">
-            <a:avLst/>
-          </a:prstGeom>
-          <a:noFill/>
-        </p:spPr>
-        <p:txBody>
-          <a:bodyPr wrap="none" anchor="t" lIns="88900" rIns="88900" tIns="38100" bIns="38100">
-            <a:noAutofit/>
-          </a:bodyPr>
-          <a:lstStyle/>
-          <a:p>
-            <a:pPr marL="279400" indent="-215900">
-              <a:lnSpc>
-                <a:spcPts val="2772"/>
-              </a:lnSpc>
-              <a:spcBef>
-                <a:spcPts val="0"/>
-              </a:spcBef>
-              <a:spcAft>
-                <a:spcPts val="0"/>
-              </a:spcAft>
-              <a:defRPr sz="2100">
-                <a:solidFill>
-                  <a:srgbClr val="20344A"/>
-                </a:solidFill>
-                <a:latin typeface="Arial"/>
-              </a:defRPr>
-              <a:buChar char="•"/>
-            </a:pPr>
-            <a:r>
-              <a:rPr sz="2100" b="0" i="0">
-                <a:solidFill>
-                  <a:srgbClr val="20344A"/>
-                </a:solidFill>
-                <a:latin typeface="Arial"/>
-              </a:rPr>
-              <a:t>Use the </a:t>
-            </a:r>
-            <a:r>
-              <a:rPr sz="2100" b="0" i="0">
-                <a:solidFill>
-                  <a:srgbClr val="007F82"/>
-                </a:solidFill>
-                <a:latin typeface="Arial"/>
-                <a:hlinkClick r:id="rId2"/>
-              </a:rPr>
-              <a:t>glossary</a:t>
-            </a:r>
-            <a:r>
-              <a:rPr sz="2100" b="0" i="0">
-                <a:solidFill>
-                  <a:srgbClr val="20344A"/>
-                </a:solidFill>
-                <a:latin typeface="Arial"/>
-              </a:rPr>
-              <a:t> and </a:t>
-            </a:r>
-            <a:r>
-              <a:rPr sz="2100" b="0" i="0">
-                <a:solidFill>
-                  <a:srgbClr val="007F82"/>
-                </a:solidFill>
-                <a:latin typeface="Arial"/>
-                <a:hlinkClick r:id="rId3"/>
-              </a:rPr>
-              <a:t>capture/comparison commands</a:t>
-            </a:r>
-            <a:r>
-              <a:rPr sz="2100" b="0" i="0">
-                <a:solidFill>
-                  <a:srgbClr val="20344A"/>
-                </a:solidFill>
-                <a:latin typeface="Arial"/>
-              </a:rPr>
-              <a:t>.</a:t>
+              <a:t>pass.</a:t>
             </a:r>
           </a:p>
         </p:txBody>
@@ -6683,14 +6745,14 @@
               </a:defRPr>
             </a:pPr>
             <a:r>
-              <a:t>SOURCE 14 / 18</a:t>
-            </a:r>
-          </a:p>
-        </p:txBody>
-      </p:sp>
-      <p:sp>
-        <p:nvSpPr>
-          <p:cNvPr id="4" name="title:line-125"/>
+              <a:t>SOURCE 15 / 18</a:t>
+            </a:r>
+          </a:p>
+        </p:txBody>
+      </p:sp>
+      <p:sp>
+        <p:nvSpPr>
+          <p:cNvPr id="4" name="title:line-138"/>
           <p:cNvSpPr txBox="1"/>
           <p:nvPr/>
         </p:nvSpPr>
@@ -6734,7 +6796,7 @@
                 </a:solidFill>
                 <a:latin typeface="Arial"/>
               </a:rPr>
-              <a:t>Inspect agreement, field by field</a:t>
+              <a:t>Inspect collaboration and every member</a:t>
             </a:r>
           </a:p>
         </p:txBody>
@@ -6786,13 +6848,95 @@
       </p:sp>
       <p:sp>
         <p:nvSpPr>
-          <p:cNvPr id="6" name="content:line-127:0"/>
+          <p:cNvPr id="6" name="content:line-140:0"/>
           <p:cNvSpPr txBox="1"/>
           <p:nvPr/>
         </p:nvSpPr>
         <p:spPr>
           <a:xfrm>
             <a:off x="594360" y="1737360"/>
+            <a:ext cx="11003279" cy="1484376"/>
+          </a:xfrm>
+          <a:prstGeom prst="rect">
+            <a:avLst/>
+          </a:prstGeom>
+          <a:noFill/>
+        </p:spPr>
+        <p:txBody>
+          <a:bodyPr wrap="none" anchor="t" lIns="88900" rIns="88900" tIns="38100" bIns="38100">
+            <a:noAutofit/>
+          </a:bodyPr>
+          <a:lstStyle/>
+          <a:p>
+            <a:pPr marL="279400" indent="-215900">
+              <a:lnSpc>
+                <a:spcPts val="2772"/>
+              </a:lnSpc>
+              <a:spcBef>
+                <a:spcPts val="0"/>
+              </a:spcBef>
+              <a:spcAft>
+                <a:spcPts val="0"/>
+              </a:spcAft>
+              <a:defRPr sz="2100">
+                <a:solidFill>
+                  <a:srgbClr val="20344A"/>
+                </a:solidFill>
+                <a:latin typeface="Arial"/>
+              </a:defRPr>
+              <a:buChar char="•"/>
+            </a:pPr>
+            <a:r>
+              <a:rPr sz="2100" b="0" i="0">
+                <a:solidFill>
+                  <a:srgbClr val="20344A"/>
+                </a:solidFill>
+                <a:latin typeface="Arial"/>
+              </a:rPr>
+              <a:t>Open feature branches, descriptive commits, PRs, and </a:t>
+            </a:r>
+            <a:br/>
+            <a:r>
+              <a:rPr sz="2100" b="0" i="0">
+                <a:solidFill>
+                  <a:srgbClr val="20344A"/>
+                </a:solidFill>
+                <a:latin typeface="Arial"/>
+              </a:rPr>
+              <a:t>meaningful teammate reviews in the Backend repo about </a:t>
+            </a:r>
+            <a:br/>
+            <a:r>
+              <a:rPr sz="2100" b="0" i="0">
+                <a:solidFill>
+                  <a:srgbClr val="20344A"/>
+                </a:solidFill>
+                <a:latin typeface="Arial"/>
+              </a:rPr>
+              <a:t>behavior, tests, or clarity; show responses/follow-up to </a:t>
+            </a:r>
+            <a:br/>
+            <a:r>
+              <a:rPr sz="2100" b="0" i="0">
+                <a:solidFill>
+                  <a:srgbClr val="20344A"/>
+                </a:solidFill>
+                <a:latin typeface="Arial"/>
+              </a:rPr>
+              <a:t>concerns.</a:t>
+            </a:r>
+          </a:p>
+        </p:txBody>
+      </p:sp>
+      <p:sp>
+        <p:nvSpPr>
+          <p:cNvPr id="7" name="content:line-141:0"/>
+          <p:cNvSpPr txBox="1"/>
+          <p:nvPr/>
+        </p:nvSpPr>
+        <p:spPr>
+          <a:xfrm>
+            <a:off x="594360" y="3285744"/>
             <a:ext cx="11003279" cy="1132332"/>
           </a:xfrm>
           <a:prstGeom prst="rect">
@@ -6831,7 +6975,7 @@
                 </a:solidFill>
                 <a:latin typeface="Arial"/>
               </a:rPr>
-              <a:t>Exact: cleaned records, identifiers, raw values, copied </a:t>
+              <a:t>For EACH student: open at least one personally authored PR </a:t>
             </a:r>
             <a:br/>
             <a:r>
@@ -6841,7 +6985,7 @@
                 </a:solidFill>
                 <a:latin typeface="Arial"/>
               </a:rPr>
-              <a:t>baselines, counts, types, structure, ordering, and nulls. </a:t>
+              <a:t>and at least one substantive review of a teammate's PR, with </a:t>
             </a:r>
             <a:br/>
             <a:r>
@@ -6851,20 +6995,20 @@
                 </a:solidFill>
                 <a:latin typeface="Arial"/>
               </a:rPr>
-              <a:t>Missing stays distinct from zero.</a:t>
-            </a:r>
-          </a:p>
-        </p:txBody>
-      </p:sp>
-      <p:sp>
-        <p:nvSpPr>
-          <p:cNvPr id="7" name="content:line-128:0"/>
-          <p:cNvSpPr txBox="1"/>
-          <p:nvPr/>
-        </p:nvSpPr>
-        <p:spPr>
-          <a:xfrm>
-            <a:off x="594360" y="2933700"/>
+              <a:t>authorship and review permalinks.</a:t>
+            </a:r>
+          </a:p>
+        </p:txBody>
+      </p:sp>
+      <p:sp>
+        <p:nvSpPr>
+          <p:cNvPr id="8" name="content:line-142:0"/>
+          <p:cNvSpPr txBox="1"/>
+          <p:nvPr/>
+        </p:nvSpPr>
+        <p:spPr>
+          <a:xfrm>
+            <a:off x="594360" y="4482084"/>
             <a:ext cx="11003279" cy="1132332"/>
           </a:xfrm>
           <a:prstGeom prst="rect">
@@ -6903,7 +7047,7 @@
                 </a:solidFill>
                 <a:latin typeface="Arial"/>
               </a:rPr>
-              <a:t>Only derived decimals receive declared tolerances documented </a:t>
+              <a:t>Each member explains their contribution, authored change, </a:t>
             </a:r>
             <a:br/>
             <a:r>
@@ -6913,7 +7057,7 @@
                 </a:solidFill>
                 <a:latin typeface="Arial"/>
               </a:rPr>
-              <a:t>in tests. In the example: change, percent_change, and </a:t>
+              <a:t>review reasoning, and any follow-up. Approval alone or “looks </a:t>
             </a:r>
             <a:br/>
             <a:r>
@@ -6923,74 +7067,21 @@
                 </a:solidFill>
                 <a:latin typeface="Arial"/>
               </a:rPr>
-              <a:t>visit-summary mean.</a:t>
-            </a:r>
-          </a:p>
-        </p:txBody>
-      </p:sp>
-      <p:sp>
-        <p:nvSpPr>
-          <p:cNvPr id="8" name="content:line-131:0"/>
-          <p:cNvSpPr txBox="1"/>
-          <p:nvPr/>
-        </p:nvSpPr>
-        <p:spPr>
-          <a:xfrm>
-            <a:off x="594360" y="4130040"/>
-            <a:ext cx="11003279" cy="377952"/>
-          </a:xfrm>
-          <a:prstGeom prst="rect">
-            <a:avLst/>
-          </a:prstGeom>
-          <a:solidFill>
-            <a:srgbClr val="EDF3F6"/>
-          </a:solidFill>
-        </p:spPr>
-        <p:txBody>
-          <a:bodyPr wrap="none" anchor="t" lIns="88900" rIns="88900" tIns="38100" bIns="38100">
-            <a:noAutofit/>
-          </a:bodyPr>
-          <a:lstStyle/>
-          <a:p>
-            <a:pPr>
-              <a:lnSpc>
-                <a:spcPts val="2376"/>
-              </a:lnSpc>
-              <a:spcBef>
-                <a:spcPts val="0"/>
-              </a:spcBef>
-              <a:spcAft>
-                <a:spcPts val="0"/>
-              </a:spcAft>
-              <a:defRPr sz="1800">
-                <a:solidFill>
-                  <a:srgbClr val="20344A"/>
-                </a:solidFill>
-                <a:latin typeface="Arial"/>
-              </a:defRPr>
-            </a:pPr>
-            <a:r>
-              <a:rPr sz="1800" b="0" i="0">
-                <a:solidFill>
-                  <a:srgbClr val="20344A"/>
-                </a:solidFill>
-                <a:latin typeface="Courier New"/>
-              </a:rPr>
-              <a:t>abs(actual - expected) &lt;= max(1e-9, 1e-9 * abs(expected))</a:t>
-            </a:r>
-          </a:p>
-        </p:txBody>
-      </p:sp>
-      <p:sp>
-        <p:nvSpPr>
-          <p:cNvPr id="9" name="content:line-134:0"/>
-          <p:cNvSpPr txBox="1"/>
-          <p:nvPr/>
-        </p:nvSpPr>
-        <p:spPr>
-          <a:xfrm>
-            <a:off x="594360" y="4507992"/>
-            <a:ext cx="11003279" cy="1484376"/>
+              <a:t>good” is insufficient.</a:t>
+            </a:r>
+          </a:p>
+        </p:txBody>
+      </p:sp>
+      <p:sp>
+        <p:nvSpPr>
+          <p:cNvPr id="9" name="content:line-143:0"/>
+          <p:cNvSpPr txBox="1"/>
+          <p:nvPr/>
+        </p:nvSpPr>
+        <p:spPr>
+          <a:xfrm>
+            <a:off x="594360" y="5678424"/>
+            <a:ext cx="11003279" cy="428244"/>
           </a:xfrm>
           <a:prstGeom prst="rect">
             <a:avLst/>
@@ -7028,37 +7119,7 @@
                 </a:solidFill>
                 <a:latin typeface="Arial"/>
               </a:rPr>
-              <a:t>The first output is the reference. Instructor opens outputs </a:t>
-            </a:r>
-            <a:br/>
-            <a:r>
-              <a:rPr sz="2100" b="0" i="0">
-                <a:solidFill>
-                  <a:srgbClr val="20344A"/>
-                </a:solidFill>
-                <a:latin typeface="Arial"/>
-              </a:rPr>
-              <a:t>and diagnostics; matching charts alone are insufficient. Do not </a:t>
-            </a:r>
-            <a:br/>
-            <a:r>
-              <a:rPr sz="2100" b="0" i="0">
-                <a:solidFill>
-                  <a:srgbClr val="20344A"/>
-                </a:solidFill>
-                <a:latin typeface="Arial"/>
-              </a:rPr>
-              <a:t>drop fields, round away differences, or widen tolerance to </a:t>
-            </a:r>
-            <a:br/>
-            <a:r>
-              <a:rPr sz="2100" b="0" i="0">
-                <a:solidFill>
-                  <a:srgbClr val="20344A"/>
-                </a:solidFill>
-                <a:latin typeface="Arial"/>
-              </a:rPr>
-              <a:t>pass.</a:t>
+              <a:t>Instructor completes an individual evidence row for every </a:t>
             </a:r>
           </a:p>
         </p:txBody>
@@ -7172,7 +7233,7 @@
               </a:defRPr>
             </a:pPr>
             <a:r>
-              <a:t>SOURCE 15 / 18</a:t>
+              <a:t>SOURCE 15 / 18  ·  CONTINUED 2</a:t>
             </a:r>
           </a:p>
         </p:txBody>
@@ -7275,14 +7336,14 @@
       </p:sp>
       <p:sp>
         <p:nvSpPr>
-          <p:cNvPr id="6" name="content:line-140:0"/>
+          <p:cNvPr id="6" name="content:line-143:1"/>
           <p:cNvSpPr txBox="1"/>
           <p:nvPr/>
         </p:nvSpPr>
         <p:spPr>
           <a:xfrm>
             <a:off x="594360" y="1737360"/>
-            <a:ext cx="11003279" cy="1132332"/>
+            <a:ext cx="11003279" cy="780288"/>
           </a:xfrm>
           <a:prstGeom prst="rect">
             <a:avLst/>
@@ -7311,16 +7372,16 @@
                 </a:solidFill>
                 <a:latin typeface="Arial"/>
               </a:defRPr>
-              <a:buChar char="•"/>
-            </a:pPr>
-            <a:r>
-              <a:rPr sz="2100" b="0" i="0">
-                <a:solidFill>
-                  <a:srgbClr val="20344A"/>
-                </a:solidFill>
-                <a:latin typeface="Arial"/>
-              </a:rPr>
-              <a:t>Open feature branches, descriptive commits, PRs, and </a:t>
+              <a:buChar char=" "/>
+            </a:pPr>
+            <a:r>
+              <a:rPr sz="2100" b="0" i="0">
+                <a:solidFill>
+                  <a:srgbClr val="20344A"/>
+                </a:solidFill>
+                <a:latin typeface="Arial"/>
+              </a:rPr>
+              <a:t>member. Sandbox practice, generated template history, and </a:t>
             </a:r>
             <a:br/>
             <a:r>
@@ -7330,223 +7391,7 @@
                 </a:solidFill>
                 <a:latin typeface="Arial"/>
               </a:rPr>
-              <a:t>meaningful teammate reviews about behavior, tests, or </a:t>
-            </a:r>
-            <a:br/>
-            <a:r>
-              <a:rPr sz="2100" b="0" i="0">
-                <a:solidFill>
-                  <a:srgbClr val="20344A"/>
-                </a:solidFill>
-                <a:latin typeface="Arial"/>
-              </a:rPr>
-              <a:t>clarity; show responses/follow-up to concerns.</a:t>
-            </a:r>
-          </a:p>
-        </p:txBody>
-      </p:sp>
-      <p:sp>
-        <p:nvSpPr>
-          <p:cNvPr id="7" name="content:line-141:0"/>
-          <p:cNvSpPr txBox="1"/>
-          <p:nvPr/>
-        </p:nvSpPr>
-        <p:spPr>
-          <a:xfrm>
-            <a:off x="594360" y="2933700"/>
-            <a:ext cx="11003279" cy="1132332"/>
-          </a:xfrm>
-          <a:prstGeom prst="rect">
-            <a:avLst/>
-          </a:prstGeom>
-          <a:noFill/>
-        </p:spPr>
-        <p:txBody>
-          <a:bodyPr wrap="none" anchor="t" lIns="88900" rIns="88900" tIns="38100" bIns="38100">
-            <a:noAutofit/>
-          </a:bodyPr>
-          <a:lstStyle/>
-          <a:p>
-            <a:pPr marL="279400" indent="-215900">
-              <a:lnSpc>
-                <a:spcPts val="2772"/>
-              </a:lnSpc>
-              <a:spcBef>
-                <a:spcPts val="0"/>
-              </a:spcBef>
-              <a:spcAft>
-                <a:spcPts val="0"/>
-              </a:spcAft>
-              <a:defRPr sz="2100">
-                <a:solidFill>
-                  <a:srgbClr val="20344A"/>
-                </a:solidFill>
-                <a:latin typeface="Arial"/>
-              </a:defRPr>
-              <a:buChar char="•"/>
-            </a:pPr>
-            <a:r>
-              <a:rPr sz="2100" b="0" i="0">
-                <a:solidFill>
-                  <a:srgbClr val="20344A"/>
-                </a:solidFill>
-                <a:latin typeface="Arial"/>
-              </a:rPr>
-              <a:t>For EACH student: open at least one personally authored PR </a:t>
-            </a:r>
-            <a:br/>
-            <a:r>
-              <a:rPr sz="2100" b="0" i="0">
-                <a:solidFill>
-                  <a:srgbClr val="20344A"/>
-                </a:solidFill>
-                <a:latin typeface="Arial"/>
-              </a:rPr>
-              <a:t>and at least one substantive review of a teammate's PR, with </a:t>
-            </a:r>
-            <a:br/>
-            <a:r>
-              <a:rPr sz="2100" b="0" i="0">
-                <a:solidFill>
-                  <a:srgbClr val="20344A"/>
-                </a:solidFill>
-                <a:latin typeface="Arial"/>
-              </a:rPr>
-              <a:t>authorship and review permalinks.</a:t>
-            </a:r>
-          </a:p>
-        </p:txBody>
-      </p:sp>
-      <p:sp>
-        <p:nvSpPr>
-          <p:cNvPr id="8" name="content:line-142:0"/>
-          <p:cNvSpPr txBox="1"/>
-          <p:nvPr/>
-        </p:nvSpPr>
-        <p:spPr>
-          <a:xfrm>
-            <a:off x="594360" y="4130040"/>
-            <a:ext cx="11003279" cy="1132332"/>
-          </a:xfrm>
-          <a:prstGeom prst="rect">
-            <a:avLst/>
-          </a:prstGeom>
-          <a:noFill/>
-        </p:spPr>
-        <p:txBody>
-          <a:bodyPr wrap="none" anchor="t" lIns="88900" rIns="88900" tIns="38100" bIns="38100">
-            <a:noAutofit/>
-          </a:bodyPr>
-          <a:lstStyle/>
-          <a:p>
-            <a:pPr marL="279400" indent="-215900">
-              <a:lnSpc>
-                <a:spcPts val="2772"/>
-              </a:lnSpc>
-              <a:spcBef>
-                <a:spcPts val="0"/>
-              </a:spcBef>
-              <a:spcAft>
-                <a:spcPts val="0"/>
-              </a:spcAft>
-              <a:defRPr sz="2100">
-                <a:solidFill>
-                  <a:srgbClr val="20344A"/>
-                </a:solidFill>
-                <a:latin typeface="Arial"/>
-              </a:defRPr>
-              <a:buChar char="•"/>
-            </a:pPr>
-            <a:r>
-              <a:rPr sz="2100" b="0" i="0">
-                <a:solidFill>
-                  <a:srgbClr val="20344A"/>
-                </a:solidFill>
-                <a:latin typeface="Arial"/>
-              </a:rPr>
-              <a:t>Each member explains their contribution, authored change, </a:t>
-            </a:r>
-            <a:br/>
-            <a:r>
-              <a:rPr sz="2100" b="0" i="0">
-                <a:solidFill>
-                  <a:srgbClr val="20344A"/>
-                </a:solidFill>
-                <a:latin typeface="Arial"/>
-              </a:rPr>
-              <a:t>review reasoning, and any follow-up. Approval alone or “looks </a:t>
-            </a:r>
-            <a:br/>
-            <a:r>
-              <a:rPr sz="2100" b="0" i="0">
-                <a:solidFill>
-                  <a:srgbClr val="20344A"/>
-                </a:solidFill>
-                <a:latin typeface="Arial"/>
-              </a:rPr>
-              <a:t>good” is insufficient.</a:t>
-            </a:r>
-          </a:p>
-        </p:txBody>
-      </p:sp>
-      <p:sp>
-        <p:nvSpPr>
-          <p:cNvPr id="9" name="content:line-143:0"/>
-          <p:cNvSpPr txBox="1"/>
-          <p:nvPr/>
-        </p:nvSpPr>
-        <p:spPr>
-          <a:xfrm>
-            <a:off x="594360" y="5326380"/>
-            <a:ext cx="11003279" cy="780288"/>
-          </a:xfrm>
-          <a:prstGeom prst="rect">
-            <a:avLst/>
-          </a:prstGeom>
-          <a:noFill/>
-        </p:spPr>
-        <p:txBody>
-          <a:bodyPr wrap="none" anchor="t" lIns="88900" rIns="88900" tIns="38100" bIns="38100">
-            <a:noAutofit/>
-          </a:bodyPr>
-          <a:lstStyle/>
-          <a:p>
-            <a:pPr marL="279400" indent="-215900">
-              <a:lnSpc>
-                <a:spcPts val="2772"/>
-              </a:lnSpc>
-              <a:spcBef>
-                <a:spcPts val="0"/>
-              </a:spcBef>
-              <a:spcAft>
-                <a:spcPts val="0"/>
-              </a:spcAft>
-              <a:defRPr sz="2100">
-                <a:solidFill>
-                  <a:srgbClr val="20344A"/>
-                </a:solidFill>
-                <a:latin typeface="Arial"/>
-              </a:defRPr>
-              <a:buChar char="•"/>
-            </a:pPr>
-            <a:r>
-              <a:rPr sz="2100" b="0" i="0">
-                <a:solidFill>
-                  <a:srgbClr val="20344A"/>
-                </a:solidFill>
-                <a:latin typeface="Arial"/>
-              </a:rPr>
-              <a:t>Instructor completes an individual evidence row for every </a:t>
-            </a:r>
-            <a:br/>
-            <a:r>
-              <a:rPr sz="2100" b="0" i="0">
-                <a:solidFill>
-                  <a:srgbClr val="20344A"/>
-                </a:solidFill>
-                <a:latin typeface="Arial"/>
-              </a:rPr>
-              <a:t>member. Template history and instructor/agent work do not </a:t>
+              <a:t>instructor/agent work do not count.</a:t>
             </a:r>
           </a:p>
         </p:txBody>
@@ -7660,14 +7505,14 @@
               </a:defRPr>
             </a:pPr>
             <a:r>
-              <a:t>SOURCE 15 / 18  ·  CONTINUED 2</a:t>
-            </a:r>
-          </a:p>
-        </p:txBody>
-      </p:sp>
-      <p:sp>
-        <p:nvSpPr>
-          <p:cNvPr id="4" name="title:line-138"/>
+              <a:t>SOURCE 16 / 18</a:t>
+            </a:r>
+          </a:p>
+        </p:txBody>
+      </p:sp>
+      <p:sp>
+        <p:nvSpPr>
+          <p:cNvPr id="4" name="title:line-147"/>
           <p:cNvSpPr txBox="1"/>
           <p:nvPr/>
         </p:nvSpPr>
@@ -7711,7 +7556,7 @@
                 </a:solidFill>
                 <a:latin typeface="Arial"/>
               </a:rPr>
-              <a:t>Inspect collaboration and every member</a:t>
+              <a:t>Questions follow the evidence</a:t>
             </a:r>
           </a:p>
         </p:txBody>
@@ -7763,14 +7608,14 @@
       </p:sp>
       <p:sp>
         <p:nvSpPr>
-          <p:cNvPr id="6" name="content:line-143:2"/>
+          <p:cNvPr id="6" name="content:line-149:0"/>
           <p:cNvSpPr txBox="1"/>
           <p:nvPr/>
         </p:nvSpPr>
         <p:spPr>
           <a:xfrm>
             <a:off x="594360" y="1737360"/>
-            <a:ext cx="11003279" cy="428244"/>
+            <a:ext cx="11003279" cy="780288"/>
           </a:xfrm>
           <a:prstGeom prst="rect">
             <a:avLst/>
@@ -7799,35 +7644,222 @@
                 </a:solidFill>
                 <a:latin typeface="Arial"/>
               </a:defRPr>
-              <a:buChar char=" "/>
-            </a:pPr>
-            <a:r>
-              <a:rPr sz="2100" b="0" i="0">
-                <a:solidFill>
-                  <a:srgbClr val="20344A"/>
-                </a:solidFill>
-                <a:latin typeface="Arial"/>
-              </a:rPr>
-              <a:t>count; see the </a:t>
-            </a:r>
-            <a:r>
-              <a:rPr sz="2100" b="0" i="0">
-                <a:solidFill>
-                  <a:srgbClr val="007F82"/>
-                </a:solidFill>
-                <a:latin typeface="Arial"/>
-                <a:hlinkClick r:id="rId2"/>
-              </a:rPr>
-              <a:t>collaboration guide</a:t>
-            </a:r>
-            <a:r>
-              <a:rPr sz="2100" b="0" i="0">
-                <a:solidFill>
-                  <a:srgbClr val="20344A"/>
-                </a:solidFill>
-                <a:latin typeface="Arial"/>
-              </a:rPr>
-              <a:t>.</a:t>
+              <a:buChar char="•"/>
+            </a:pPr>
+            <a:r>
+              <a:rPr sz="2100" b="0" i="0">
+                <a:solidFill>
+                  <a:srgbClr val="20344A"/>
+                </a:solidFill>
+                <a:latin typeface="Arial"/>
+              </a:rPr>
+              <a:t>Why does this input fail? Open the rejection and the test that </a:t>
+            </a:r>
+            <a:br/>
+            <a:r>
+              <a:rPr sz="2100" b="0" i="0">
+                <a:solidFill>
+                  <a:srgbClr val="20344A"/>
+                </a:solidFill>
+                <a:latin typeface="Arial"/>
+              </a:rPr>
+              <a:t>establishes the rule.</a:t>
+            </a:r>
+          </a:p>
+        </p:txBody>
+      </p:sp>
+      <p:sp>
+        <p:nvSpPr>
+          <p:cNvPr id="7" name="content:line-150:0"/>
+          <p:cNvSpPr txBox="1"/>
+          <p:nvPr/>
+        </p:nvSpPr>
+        <p:spPr>
+          <a:xfrm>
+            <a:off x="594360" y="2581656"/>
+            <a:ext cx="11003279" cy="1132332"/>
+          </a:xfrm>
+          <a:prstGeom prst="rect">
+            <a:avLst/>
+          </a:prstGeom>
+          <a:noFill/>
+        </p:spPr>
+        <p:txBody>
+          <a:bodyPr wrap="none" anchor="t" lIns="88900" rIns="88900" tIns="38100" bIns="38100">
+            <a:noAutofit/>
+          </a:bodyPr>
+          <a:lstStyle/>
+          <a:p>
+            <a:pPr marL="279400" indent="-215900">
+              <a:lnSpc>
+                <a:spcPts val="2772"/>
+              </a:lnSpc>
+              <a:spcBef>
+                <a:spcPts val="0"/>
+              </a:spcBef>
+              <a:spcAft>
+                <a:spcPts val="0"/>
+              </a:spcAft>
+              <a:defRPr sz="2100">
+                <a:solidFill>
+                  <a:srgbClr val="20344A"/>
+                </a:solidFill>
+                <a:latin typeface="Arial"/>
+              </a:defRPr>
+              <a:buChar char="•"/>
+            </a:pPr>
+            <a:r>
+              <a:rPr sz="2100" b="0" i="0">
+                <a:solidFill>
+                  <a:srgbClr val="20344A"/>
+                </a:solidFill>
+                <a:latin typeface="Arial"/>
+              </a:rPr>
+              <a:t>Which code and input produced these outputs? Open the </a:t>
+            </a:r>
+            <a:br/>
+            <a:r>
+              <a:rPr sz="2100" b="0" i="0">
+                <a:solidFill>
+                  <a:srgbClr val="20344A"/>
+                </a:solidFill>
+                <a:latin typeface="Arial"/>
+              </a:rPr>
+              <a:t>commit and capture fingerprints, then explain environment </a:t>
+            </a:r>
+            <a:br/>
+            <a:r>
+              <a:rPr sz="2100" b="0" i="0">
+                <a:solidFill>
+                  <a:srgbClr val="20344A"/>
+                </a:solidFill>
+                <a:latin typeface="Arial"/>
+              </a:rPr>
+              <a:t>differences.</a:t>
+            </a:r>
+          </a:p>
+        </p:txBody>
+      </p:sp>
+      <p:sp>
+        <p:nvSpPr>
+          <p:cNvPr id="8" name="content:line-151:0"/>
+          <p:cNvSpPr txBox="1"/>
+          <p:nvPr/>
+        </p:nvSpPr>
+        <p:spPr>
+          <a:xfrm>
+            <a:off x="594360" y="3777996"/>
+            <a:ext cx="11003279" cy="780288"/>
+          </a:xfrm>
+          <a:prstGeom prst="rect">
+            <a:avLst/>
+          </a:prstGeom>
+          <a:noFill/>
+        </p:spPr>
+        <p:txBody>
+          <a:bodyPr wrap="none" anchor="t" lIns="88900" rIns="88900" tIns="38100" bIns="38100">
+            <a:noAutofit/>
+          </a:bodyPr>
+          <a:lstStyle/>
+          <a:p>
+            <a:pPr marL="279400" indent="-215900">
+              <a:lnSpc>
+                <a:spcPts val="2772"/>
+              </a:lnSpc>
+              <a:spcBef>
+                <a:spcPts val="0"/>
+              </a:spcBef>
+              <a:spcAft>
+                <a:spcPts val="0"/>
+              </a:spcAft>
+              <a:defRPr sz="2100">
+                <a:solidFill>
+                  <a:srgbClr val="20344A"/>
+                </a:solidFill>
+                <a:latin typeface="Arial"/>
+              </a:defRPr>
+              <a:buChar char="•"/>
+            </a:pPr>
+            <a:r>
+              <a:rPr sz="2100" b="0" i="0">
+                <a:solidFill>
+                  <a:srgbClr val="20344A"/>
+                </a:solidFill>
+                <a:latin typeface="Arial"/>
+              </a:rPr>
+              <a:t>Which fields compare exactly, and why is a derived value </a:t>
+            </a:r>
+            <a:br/>
+            <a:r>
+              <a:rPr sz="2100" b="0" i="0">
+                <a:solidFill>
+                  <a:srgbClr val="20344A"/>
+                </a:solidFill>
+                <a:latin typeface="Arial"/>
+              </a:rPr>
+              <a:t>allowed tolerance? Open the comparison and its tests.</a:t>
+            </a:r>
+          </a:p>
+        </p:txBody>
+      </p:sp>
+      <p:sp>
+        <p:nvSpPr>
+          <p:cNvPr id="9" name="content:line-152:0"/>
+          <p:cNvSpPr txBox="1"/>
+          <p:nvPr/>
+        </p:nvSpPr>
+        <p:spPr>
+          <a:xfrm>
+            <a:off x="594360" y="4622292"/>
+            <a:ext cx="11003279" cy="780288"/>
+          </a:xfrm>
+          <a:prstGeom prst="rect">
+            <a:avLst/>
+          </a:prstGeom>
+          <a:noFill/>
+        </p:spPr>
+        <p:txBody>
+          <a:bodyPr wrap="none" anchor="t" lIns="88900" rIns="88900" tIns="38100" bIns="38100">
+            <a:noAutofit/>
+          </a:bodyPr>
+          <a:lstStyle/>
+          <a:p>
+            <a:pPr marL="279400" indent="-215900">
+              <a:lnSpc>
+                <a:spcPts val="2772"/>
+              </a:lnSpc>
+              <a:spcBef>
+                <a:spcPts val="0"/>
+              </a:spcBef>
+              <a:spcAft>
+                <a:spcPts val="0"/>
+              </a:spcAft>
+              <a:defRPr sz="2100">
+                <a:solidFill>
+                  <a:srgbClr val="20344A"/>
+                </a:solidFill>
+                <a:latin typeface="Arial"/>
+              </a:defRPr>
+              <a:buChar char="•"/>
+            </a:pPr>
+            <a:r>
+              <a:rPr sz="2100" b="0" i="0">
+                <a:solidFill>
+                  <a:srgbClr val="20344A"/>
+                </a:solidFill>
+                <a:latin typeface="Arial"/>
+              </a:rPr>
+              <a:t>What did you change or ask a teammate to improve? Open your </a:t>
+            </a:r>
+            <a:br/>
+            <a:r>
+              <a:rPr sz="2100" b="0" i="0">
+                <a:solidFill>
+                  <a:srgbClr val="20344A"/>
+                </a:solidFill>
+                <a:latin typeface="Arial"/>
+              </a:rPr>
+              <a:t>PR or review and explain the result.</a:t>
             </a:r>
           </a:p>
         </p:txBody>
@@ -7941,14 +7973,14 @@
               </a:defRPr>
             </a:pPr>
             <a:r>
-              <a:t>SOURCE 16 / 18</a:t>
-            </a:r>
-          </a:p>
-        </p:txBody>
-      </p:sp>
-      <p:sp>
-        <p:nvSpPr>
-          <p:cNvPr id="4" name="title:line-147"/>
+              <a:t>SOURCE 17 / 18</a:t>
+            </a:r>
+          </a:p>
+        </p:txBody>
+      </p:sp>
+      <p:sp>
+        <p:nvSpPr>
+          <p:cNvPr id="4" name="title:line-156"/>
           <p:cNvSpPr txBox="1"/>
           <p:nvPr/>
         </p:nvSpPr>
@@ -7992,7 +8024,7 @@
                 </a:solidFill>
                 <a:latin typeface="Arial"/>
               </a:rPr>
-              <a:t>Questions follow the evidence</a:t>
+              <a:t>Shared break and remaining groups</a:t>
             </a:r>
           </a:p>
         </p:txBody>
@@ -8044,7 +8076,7 @@
       </p:sp>
       <p:sp>
         <p:nvSpPr>
-          <p:cNvPr id="6" name="content:line-149:0"/>
+          <p:cNvPr id="6" name="content:line-158:0"/>
           <p:cNvSpPr txBox="1"/>
           <p:nvPr/>
         </p:nvSpPr>
@@ -8089,7 +8121,7 @@
                 </a:solidFill>
                 <a:latin typeface="Arial"/>
               </a:rPr>
-              <a:t>Why does this input fail? Open the rejection and the test that </a:t>
+              <a:t>Take the reserved 10-minute break at the published slot </a:t>
             </a:r>
             <a:br/>
             <a:r>
@@ -8099,21 +8131,21 @@
                 </a:solidFill>
                 <a:latin typeface="Arial"/>
               </a:rPr>
-              <a:t>establishes the rule.</a:t>
-            </a:r>
-          </a:p>
-        </p:txBody>
-      </p:sp>
-      <p:sp>
-        <p:nvSpPr>
-          <p:cNvPr id="7" name="content:line-150:0"/>
+              <a:t>boundary.</a:t>
+            </a:r>
+          </a:p>
+        </p:txBody>
+      </p:sp>
+      <p:sp>
+        <p:nvSpPr>
+          <p:cNvPr id="7" name="content:line-159:0"/>
           <p:cNvSpPr txBox="1"/>
           <p:nvPr/>
         </p:nvSpPr>
         <p:spPr>
           <a:xfrm>
             <a:off x="594360" y="2581656"/>
-            <a:ext cx="11003279" cy="1132332"/>
+            <a:ext cx="11003279" cy="780288"/>
           </a:xfrm>
           <a:prstGeom prst="rect">
             <a:avLst/>
@@ -8151,7 +8183,7 @@
                 </a:solidFill>
                 <a:latin typeface="Arial"/>
               </a:rPr>
-              <a:t>Which code and input produced these outputs? Open the </a:t>
+              <a:t>Resume with the next group's live demo, evidence inspection, </a:t>
             </a:r>
             <a:br/>
             <a:r>
@@ -8161,7 +8193,59 @@
                 </a:solidFill>
                 <a:latin typeface="Arial"/>
               </a:rPr>
-              <a:t>commit and capture fingerprints, then explain environment </a:t>
+              <a:t>and questions using the same S allocation.</a:t>
+            </a:r>
+          </a:p>
+        </p:txBody>
+      </p:sp>
+      <p:sp>
+        <p:nvSpPr>
+          <p:cNvPr id="8" name="content:line-160:0"/>
+          <p:cNvSpPr txBox="1"/>
+          <p:nvPr/>
+        </p:nvSpPr>
+        <p:spPr>
+          <a:xfrm>
+            <a:off x="594360" y="3425952"/>
+            <a:ext cx="11003279" cy="780288"/>
+          </a:xfrm>
+          <a:prstGeom prst="rect">
+            <a:avLst/>
+          </a:prstGeom>
+          <a:noFill/>
+        </p:spPr>
+        <p:txBody>
+          <a:bodyPr wrap="none" anchor="t" lIns="88900" rIns="88900" tIns="38100" bIns="38100">
+            <a:noAutofit/>
+          </a:bodyPr>
+          <a:lstStyle/>
+          <a:p>
+            <a:pPr marL="279400" indent="-215900">
+              <a:lnSpc>
+                <a:spcPts val="2772"/>
+              </a:lnSpc>
+              <a:spcBef>
+                <a:spcPts val="0"/>
+              </a:spcBef>
+              <a:spcAft>
+                <a:spcPts val="0"/>
+              </a:spcAft>
+              <a:defRPr sz="2100">
+                <a:solidFill>
+                  <a:srgbClr val="20344A"/>
+                </a:solidFill>
+                <a:latin typeface="Arial"/>
+              </a:defRPr>
+              <a:buChar char="•"/>
+            </a:pPr>
+            <a:r>
+              <a:rPr sz="2100" b="0" i="0">
+                <a:solidFill>
+                  <a:srgbClr val="20344A"/>
+                </a:solidFill>
+                <a:latin typeface="Arial"/>
+              </a:rPr>
+              <a:t>Every group uses the same mandatory checklist; keep the </a:t>
             </a:r>
             <a:br/>
             <a:r>
@@ -8171,131 +8255,7 @@
                 </a:solidFill>
                 <a:latin typeface="Arial"/>
               </a:rPr>
-              <a:t>differences.</a:t>
-            </a:r>
-          </a:p>
-        </p:txBody>
-      </p:sp>
-      <p:sp>
-        <p:nvSpPr>
-          <p:cNvPr id="8" name="content:line-151:0"/>
-          <p:cNvSpPr txBox="1"/>
-          <p:nvPr/>
-        </p:nvSpPr>
-        <p:spPr>
-          <a:xfrm>
-            <a:off x="594360" y="3777996"/>
-            <a:ext cx="11003279" cy="780288"/>
-          </a:xfrm>
-          <a:prstGeom prst="rect">
-            <a:avLst/>
-          </a:prstGeom>
-          <a:noFill/>
-        </p:spPr>
-        <p:txBody>
-          <a:bodyPr wrap="none" anchor="t" lIns="88900" rIns="88900" tIns="38100" bIns="38100">
-            <a:noAutofit/>
-          </a:bodyPr>
-          <a:lstStyle/>
-          <a:p>
-            <a:pPr marL="279400" indent="-215900">
-              <a:lnSpc>
-                <a:spcPts val="2772"/>
-              </a:lnSpc>
-              <a:spcBef>
-                <a:spcPts val="0"/>
-              </a:spcBef>
-              <a:spcAft>
-                <a:spcPts val="0"/>
-              </a:spcAft>
-              <a:defRPr sz="2100">
-                <a:solidFill>
-                  <a:srgbClr val="20344A"/>
-                </a:solidFill>
-                <a:latin typeface="Arial"/>
-              </a:defRPr>
-              <a:buChar char="•"/>
-            </a:pPr>
-            <a:r>
-              <a:rPr sz="2100" b="0" i="0">
-                <a:solidFill>
-                  <a:srgbClr val="20344A"/>
-                </a:solidFill>
-                <a:latin typeface="Arial"/>
-              </a:rPr>
-              <a:t>Which fields compare exactly, and why is a derived value </a:t>
-            </a:r>
-            <a:br/>
-            <a:r>
-              <a:rPr sz="2100" b="0" i="0">
-                <a:solidFill>
-                  <a:srgbClr val="20344A"/>
-                </a:solidFill>
-                <a:latin typeface="Arial"/>
-              </a:rPr>
-              <a:t>allowed tolerance? Open the comparison and its tests.</a:t>
-            </a:r>
-          </a:p>
-        </p:txBody>
-      </p:sp>
-      <p:sp>
-        <p:nvSpPr>
-          <p:cNvPr id="9" name="content:line-152:0"/>
-          <p:cNvSpPr txBox="1"/>
-          <p:nvPr/>
-        </p:nvSpPr>
-        <p:spPr>
-          <a:xfrm>
-            <a:off x="594360" y="4622292"/>
-            <a:ext cx="11003279" cy="780288"/>
-          </a:xfrm>
-          <a:prstGeom prst="rect">
-            <a:avLst/>
-          </a:prstGeom>
-          <a:noFill/>
-        </p:spPr>
-        <p:txBody>
-          <a:bodyPr wrap="none" anchor="t" lIns="88900" rIns="88900" tIns="38100" bIns="38100">
-            <a:noAutofit/>
-          </a:bodyPr>
-          <a:lstStyle/>
-          <a:p>
-            <a:pPr marL="279400" indent="-215900">
-              <a:lnSpc>
-                <a:spcPts val="2772"/>
-              </a:lnSpc>
-              <a:spcBef>
-                <a:spcPts val="0"/>
-              </a:spcBef>
-              <a:spcAft>
-                <a:spcPts val="0"/>
-              </a:spcAft>
-              <a:defRPr sz="2100">
-                <a:solidFill>
-                  <a:srgbClr val="20344A"/>
-                </a:solidFill>
-                <a:latin typeface="Arial"/>
-              </a:defRPr>
-              <a:buChar char="•"/>
-            </a:pPr>
-            <a:r>
-              <a:rPr sz="2100" b="0" i="0">
-                <a:solidFill>
-                  <a:srgbClr val="20344A"/>
-                </a:solidFill>
-                <a:latin typeface="Arial"/>
-              </a:rPr>
-              <a:t>What did you change or ask a teammate to improve? Open your </a:t>
-            </a:r>
-            <a:br/>
-            <a:r>
-              <a:rPr sz="2100" b="0" i="0">
-                <a:solidFill>
-                  <a:srgbClr val="20344A"/>
-                </a:solidFill>
-                <a:latin typeface="Arial"/>
-              </a:rPr>
-              <a:t>PR or review and explain the result.</a:t>
+              <a:t>reserved five-minute closing within the 170 minutes.</a:t>
             </a:r>
           </a:p>
         </p:txBody>
@@ -8680,14 +8640,14 @@
               </a:defRPr>
             </a:pPr>
             <a:r>
-              <a:t>SOURCE 17 / 18</a:t>
-            </a:r>
-          </a:p>
-        </p:txBody>
-      </p:sp>
-      <p:sp>
-        <p:nvSpPr>
-          <p:cNvPr id="4" name="title:line-156"/>
+              <a:t>SOURCE 18 / 18</a:t>
+            </a:r>
+          </a:p>
+        </p:txBody>
+      </p:sp>
+      <p:sp>
+        <p:nvSpPr>
+          <p:cNvPr id="4" name="title:line-164"/>
           <p:cNvSpPr txBox="1"/>
           <p:nvPr/>
         </p:nvSpPr>
@@ -8731,7 +8691,7 @@
                 </a:solidFill>
                 <a:latin typeface="Arial"/>
               </a:rPr>
-              <a:t>Shared break and remaining groups</a:t>
+              <a:t>Closing: connect the engineering evidence</a:t>
             </a:r>
           </a:p>
         </p:txBody>
@@ -8783,13 +8743,85 @@
       </p:sp>
       <p:sp>
         <p:nvSpPr>
-          <p:cNvPr id="6" name="content:line-158:0"/>
+          <p:cNvPr id="6" name="content:line-166:0"/>
           <p:cNvSpPr txBox="1"/>
           <p:nvPr/>
         </p:nvSpPr>
         <p:spPr>
           <a:xfrm>
             <a:off x="594360" y="1737360"/>
+            <a:ext cx="11003279" cy="1132332"/>
+          </a:xfrm>
+          <a:prstGeom prst="rect">
+            <a:avLst/>
+          </a:prstGeom>
+          <a:noFill/>
+        </p:spPr>
+        <p:txBody>
+          <a:bodyPr wrap="none" anchor="t" lIns="88900" rIns="88900" tIns="38100" bIns="38100">
+            <a:noAutofit/>
+          </a:bodyPr>
+          <a:lstStyle/>
+          <a:p>
+            <a:pPr marL="279400" indent="-215900">
+              <a:lnSpc>
+                <a:spcPts val="2772"/>
+              </a:lnSpc>
+              <a:spcBef>
+                <a:spcPts val="0"/>
+              </a:spcBef>
+              <a:spcAft>
+                <a:spcPts val="0"/>
+              </a:spcAft>
+              <a:defRPr sz="2100">
+                <a:solidFill>
+                  <a:srgbClr val="20344A"/>
+                </a:solidFill>
+                <a:latin typeface="Arial"/>
+              </a:defRPr>
+              <a:buChar char="•"/>
+            </a:pPr>
+            <a:r>
+              <a:rPr sz="2100" b="0" i="0">
+                <a:solidFill>
+                  <a:srgbClr val="20344A"/>
+                </a:solidFill>
+                <a:latin typeface="Arial"/>
+              </a:rPr>
+              <a:t>Use the final five minutes to connect environment, package </a:t>
+            </a:r>
+            <a:br/>
+            <a:r>
+              <a:rPr sz="2100" b="0" i="0">
+                <a:solidFill>
+                  <a:srgbClr val="20344A"/>
+                </a:solidFill>
+                <a:latin typeface="Arial"/>
+              </a:rPr>
+              <a:t>and Release, API/UI, containers, tests, comparisons, and peer </a:t>
+            </a:r>
+            <a:br/>
+            <a:r>
+              <a:rPr sz="2100" b="0" i="0">
+                <a:solidFill>
+                  <a:srgbClr val="20344A"/>
+                </a:solidFill>
+                <a:latin typeface="Arial"/>
+              </a:rPr>
+              <a:t>review.</a:t>
+            </a:r>
+          </a:p>
+        </p:txBody>
+      </p:sp>
+      <p:sp>
+        <p:nvSpPr>
+          <p:cNvPr id="7" name="content:line-167:0"/>
+          <p:cNvSpPr txBox="1"/>
+          <p:nvPr/>
+        </p:nvSpPr>
+        <p:spPr>
+          <a:xfrm>
+            <a:off x="594360" y="2933700"/>
             <a:ext cx="11003279" cy="780288"/>
           </a:xfrm>
           <a:prstGeom prst="rect">
@@ -8828,7 +8860,7 @@
                 </a:solidFill>
                 <a:latin typeface="Arial"/>
               </a:rPr>
-              <a:t>Take the reserved 15-minute break at the published slot </a:t>
+              <a:t>Pass requires every mandatory group row and every student's </a:t>
             </a:r>
             <a:br/>
             <a:r>
@@ -8838,21 +8870,21 @@
                 </a:solidFill>
                 <a:latin typeface="Arial"/>
               </a:rPr>
-              <a:t>boundary.</a:t>
-            </a:r>
-          </a:p>
-        </p:txBody>
-      </p:sp>
-      <p:sp>
-        <p:nvSpPr>
-          <p:cNvPr id="7" name="content:line-159:0"/>
-          <p:cNvSpPr txBox="1"/>
-          <p:nvPr/>
-        </p:nvSpPr>
-        <p:spPr>
-          <a:xfrm>
-            <a:off x="594360" y="2581656"/>
-            <a:ext cx="11003279" cy="780288"/>
+              <a:t>individual participation requirement to pass.</a:t>
+            </a:r>
+          </a:p>
+        </p:txBody>
+      </p:sp>
+      <p:sp>
+        <p:nvSpPr>
+          <p:cNvPr id="8" name="content:line-168:0"/>
+          <p:cNvSpPr txBox="1"/>
+          <p:nvPr/>
+        </p:nvSpPr>
+        <p:spPr>
+          <a:xfrm>
+            <a:off x="594360" y="3777996"/>
+            <a:ext cx="11003279" cy="1132332"/>
           </a:xfrm>
           <a:prstGeom prst="rect">
             <a:avLst/>
@@ -8890,7 +8922,7 @@
                 </a:solidFill>
                 <a:latin typeface="Arial"/>
               </a:rPr>
-              <a:t>Resume with the next group's live demo, evidence inspection, </a:t>
+              <a:t>Instructor records failed rows and reasons at the </a:t>
             </a:r>
             <a:br/>
             <a:r>
@@ -8900,59 +8932,7 @@
                 </a:solidFill>
                 <a:latin typeface="Arial"/>
               </a:rPr>
-              <a:t>and questions using the same S allocation.</a:t>
-            </a:r>
-          </a:p>
-        </p:txBody>
-      </p:sp>
-      <p:sp>
-        <p:nvSpPr>
-          <p:cNvPr id="8" name="content:line-160:0"/>
-          <p:cNvSpPr txBox="1"/>
-          <p:nvPr/>
-        </p:nvSpPr>
-        <p:spPr>
-          <a:xfrm>
-            <a:off x="594360" y="3425952"/>
-            <a:ext cx="11003279" cy="780288"/>
-          </a:xfrm>
-          <a:prstGeom prst="rect">
-            <a:avLst/>
-          </a:prstGeom>
-          <a:noFill/>
-        </p:spPr>
-        <p:txBody>
-          <a:bodyPr wrap="none" anchor="t" lIns="88900" rIns="88900" tIns="38100" bIns="38100">
-            <a:noAutofit/>
-          </a:bodyPr>
-          <a:lstStyle/>
-          <a:p>
-            <a:pPr marL="279400" indent="-215900">
-              <a:lnSpc>
-                <a:spcPts val="2772"/>
-              </a:lnSpc>
-              <a:spcBef>
-                <a:spcPts val="0"/>
-              </a:spcBef>
-              <a:spcAft>
-                <a:spcPts val="0"/>
-              </a:spcAft>
-              <a:defRPr sz="2100">
-                <a:solidFill>
-                  <a:srgbClr val="20344A"/>
-                </a:solidFill>
-                <a:latin typeface="Arial"/>
-              </a:defRPr>
-              <a:buChar char="•"/>
-            </a:pPr>
-            <a:r>
-              <a:rPr sz="2100" b="0" i="0">
-                <a:solidFill>
-                  <a:srgbClr val="20344A"/>
-                </a:solidFill>
-                <a:latin typeface="Arial"/>
-              </a:rPr>
-              <a:t>Every group uses the same mandatory checklist; keep the </a:t>
+              <a:t>presentation; no averaging or complexity bonuses, and no later </a:t>
             </a:r>
             <a:br/>
             <a:r>
@@ -8962,412 +8942,6 @@
                 </a:solidFill>
                 <a:latin typeface="Arial"/>
               </a:rPr>
-              <a:t>reserved five-minute closing within the three hours.</a:t>
-            </a:r>
-          </a:p>
-        </p:txBody>
-      </p:sp>
-    </p:spTree>
-  </p:cSld>
-  <p:clrMapOvr>
-    <a:masterClrMapping/>
-  </p:clrMapOvr>
-</p:sld>
-</file>
-
-<file path=ppt/slides/slide21.xml><?xml version="1.0" encoding="utf-8"?>
-<p:sld xmlns:a="http://schemas.openxmlformats.org/drawingml/2006/main" xmlns:p="http://schemas.openxmlformats.org/presentationml/2006/main" xmlns:r="http://schemas.openxmlformats.org/officeDocument/2006/relationships">
-  <p:cSld>
-    <p:bg>
-      <p:bgPr>
-        <a:solidFill>
-          <a:srgbClr val="FAFCFD"/>
-        </a:solidFill>
-        <a:effectLst/>
-      </p:bgPr>
-    </p:bg>
-    <p:spTree>
-      <p:nvGrpSpPr>
-        <p:cNvPr id="1" name=""/>
-        <p:cNvGrpSpPr/>
-        <p:nvPr/>
-      </p:nvGrpSpPr>
-      <p:grpSpPr/>
-      <p:sp>
-        <p:nvSpPr>
-          <p:cNvPr id="2" name="accent"/>
-          <p:cNvSpPr/>
-          <p:nvPr/>
-        </p:nvSpPr>
-        <p:spPr>
-          <a:xfrm>
-            <a:off x="0" y="0"/>
-            <a:ext cx="12191999" cy="64008"/>
-          </a:xfrm>
-          <a:prstGeom prst="rect">
-            <a:avLst/>
-          </a:prstGeom>
-          <a:solidFill>
-            <a:srgbClr val="007F82"/>
-          </a:solidFill>
-          <a:ln>
-            <a:noFill/>
-          </a:ln>
-        </p:spPr>
-        <p:style>
-          <a:lnRef idx="1">
-            <a:schemeClr val="accent1"/>
-          </a:lnRef>
-          <a:fillRef idx="3">
-            <a:schemeClr val="accent1"/>
-          </a:fillRef>
-          <a:effectRef idx="2">
-            <a:schemeClr val="accent1"/>
-          </a:effectRef>
-          <a:fontRef idx="minor">
-            <a:schemeClr val="lt1"/>
-          </a:fontRef>
-        </p:style>
-        <p:txBody>
-          <a:bodyPr rtlCol="0" anchor="ctr"/>
-          <a:lstStyle/>
-          <a:p>
-            <a:pPr algn="ctr"/>
-          </a:p>
-        </p:txBody>
-      </p:sp>
-      <p:sp>
-        <p:nvSpPr>
-          <p:cNvPr id="3" name="section"/>
-          <p:cNvSpPr txBox="1"/>
-          <p:nvPr/>
-        </p:nvSpPr>
-        <p:spPr>
-          <a:xfrm>
-            <a:off x="594360" y="201168"/>
-            <a:ext cx="11003279" cy="256032"/>
-          </a:xfrm>
-          <a:prstGeom prst="rect">
-            <a:avLst/>
-          </a:prstGeom>
-          <a:noFill/>
-        </p:spPr>
-        <p:txBody>
-          <a:bodyPr wrap="none" anchor="t" lIns="88900" rIns="88900" tIns="38100" bIns="38100">
-            <a:noAutofit/>
-          </a:bodyPr>
-          <a:lstStyle/>
-          <a:p>
-            <a:pPr>
-              <a:lnSpc>
-                <a:spcPts val="1452"/>
-              </a:lnSpc>
-              <a:spcBef>
-                <a:spcPts val="0"/>
-              </a:spcBef>
-              <a:spcAft>
-                <a:spcPts val="0"/>
-              </a:spcAft>
-              <a:defRPr sz="1100">
-                <a:solidFill>
-                  <a:srgbClr val="53677A"/>
-                </a:solidFill>
-                <a:latin typeface="Arial"/>
-              </a:defRPr>
-            </a:pPr>
-            <a:r>
-              <a:t>SOURCE 18 / 18</a:t>
-            </a:r>
-          </a:p>
-        </p:txBody>
-      </p:sp>
-      <p:sp>
-        <p:nvSpPr>
-          <p:cNvPr id="4" name="title:line-164"/>
-          <p:cNvSpPr txBox="1"/>
-          <p:nvPr/>
-        </p:nvSpPr>
-        <p:spPr>
-          <a:xfrm>
-            <a:off x="594360" y="530352"/>
-            <a:ext cx="11003279" cy="1161288"/>
-          </a:xfrm>
-          <a:prstGeom prst="rect">
-            <a:avLst/>
-          </a:prstGeom>
-          <a:noFill/>
-        </p:spPr>
-        <p:txBody>
-          <a:bodyPr wrap="none" anchor="t" lIns="88900" rIns="88900" tIns="38100" bIns="38100">
-            <a:noAutofit/>
-          </a:bodyPr>
-          <a:lstStyle/>
-          <a:p>
-            <a:pPr>
-              <a:lnSpc>
-                <a:spcPts val="4000"/>
-              </a:lnSpc>
-              <a:spcBef>
-                <a:spcPts val="0"/>
-              </a:spcBef>
-              <a:spcAft>
-                <a:spcPts val="0"/>
-              </a:spcAft>
-              <a:defRPr sz="3200">
-                <a:solidFill>
-                  <a:srgbClr val="20344A"/>
-                </a:solidFill>
-                <a:latin typeface="Arial"/>
-              </a:defRPr>
-            </a:pPr>
-            <a:r>
-              <a:rPr sz="3200" b="0" i="0">
-                <a:solidFill>
-                  <a:srgbClr val="20344A"/>
-                </a:solidFill>
-                <a:latin typeface="Arial"/>
-              </a:rPr>
-              <a:t>Closing: connect the engineering evidence</a:t>
-            </a:r>
-          </a:p>
-        </p:txBody>
-      </p:sp>
-      <p:sp>
-        <p:nvSpPr>
-          <p:cNvPr id="5" name="footer"/>
-          <p:cNvSpPr txBox="1"/>
-          <p:nvPr/>
-        </p:nvSpPr>
-        <p:spPr>
-          <a:xfrm>
-            <a:off x="594360" y="6510528"/>
-            <a:ext cx="11003279" cy="219456"/>
-          </a:xfrm>
-          <a:prstGeom prst="rect">
-            <a:avLst/>
-          </a:prstGeom>
-          <a:noFill/>
-        </p:spPr>
-        <p:txBody>
-          <a:bodyPr wrap="none" anchor="t" lIns="88900" rIns="88900" tIns="38100" bIns="38100">
-            <a:noAutofit/>
-          </a:bodyPr>
-          <a:lstStyle/>
-          <a:p>
-            <a:pPr>
-              <a:lnSpc>
-                <a:spcPts val="1320"/>
-              </a:lnSpc>
-              <a:spcBef>
-                <a:spcPts val="0"/>
-              </a:spcBef>
-              <a:spcAft>
-                <a:spcPts val="0"/>
-              </a:spcAft>
-              <a:defRPr sz="1000">
-                <a:solidFill>
-                  <a:srgbClr val="53677A"/>
-                </a:solidFill>
-                <a:latin typeface="Arial"/>
-              </a:defRPr>
-            </a:pPr>
-            <a:r>
-              <a:t>session-5.md   ·   21</a:t>
-            </a:r>
-          </a:p>
-        </p:txBody>
-      </p:sp>
-      <p:sp>
-        <p:nvSpPr>
-          <p:cNvPr id="6" name="content:line-166:0"/>
-          <p:cNvSpPr txBox="1"/>
-          <p:nvPr/>
-        </p:nvSpPr>
-        <p:spPr>
-          <a:xfrm>
-            <a:off x="594360" y="1737360"/>
-            <a:ext cx="11003279" cy="780288"/>
-          </a:xfrm>
-          <a:prstGeom prst="rect">
-            <a:avLst/>
-          </a:prstGeom>
-          <a:noFill/>
-        </p:spPr>
-        <p:txBody>
-          <a:bodyPr wrap="none" anchor="t" lIns="88900" rIns="88900" tIns="38100" bIns="38100">
-            <a:noAutofit/>
-          </a:bodyPr>
-          <a:lstStyle/>
-          <a:p>
-            <a:pPr marL="279400" indent="-215900">
-              <a:lnSpc>
-                <a:spcPts val="2772"/>
-              </a:lnSpc>
-              <a:spcBef>
-                <a:spcPts val="0"/>
-              </a:spcBef>
-              <a:spcAft>
-                <a:spcPts val="0"/>
-              </a:spcAft>
-              <a:defRPr sz="2100">
-                <a:solidFill>
-                  <a:srgbClr val="20344A"/>
-                </a:solidFill>
-                <a:latin typeface="Arial"/>
-              </a:defRPr>
-              <a:buChar char="•"/>
-            </a:pPr>
-            <a:r>
-              <a:rPr sz="2100" b="0" i="0">
-                <a:solidFill>
-                  <a:srgbClr val="20344A"/>
-                </a:solidFill>
-                <a:latin typeface="Arial"/>
-              </a:rPr>
-              <a:t>Use the final five minutes to connect environment, package, </a:t>
-            </a:r>
-            <a:br/>
-            <a:r>
-              <a:rPr sz="2100" b="0" i="0">
-                <a:solidFill>
-                  <a:srgbClr val="20344A"/>
-                </a:solidFill>
-                <a:latin typeface="Arial"/>
-              </a:rPr>
-              <a:t>API/UI, containers, tests, comparisons, and peer review.</a:t>
-            </a:r>
-          </a:p>
-        </p:txBody>
-      </p:sp>
-      <p:sp>
-        <p:nvSpPr>
-          <p:cNvPr id="7" name="content:line-167:0"/>
-          <p:cNvSpPr txBox="1"/>
-          <p:nvPr/>
-        </p:nvSpPr>
-        <p:spPr>
-          <a:xfrm>
-            <a:off x="594360" y="2581656"/>
-            <a:ext cx="11003279" cy="780288"/>
-          </a:xfrm>
-          <a:prstGeom prst="rect">
-            <a:avLst/>
-          </a:prstGeom>
-          <a:noFill/>
-        </p:spPr>
-        <p:txBody>
-          <a:bodyPr wrap="none" anchor="t" lIns="88900" rIns="88900" tIns="38100" bIns="38100">
-            <a:noAutofit/>
-          </a:bodyPr>
-          <a:lstStyle/>
-          <a:p>
-            <a:pPr marL="279400" indent="-215900">
-              <a:lnSpc>
-                <a:spcPts val="2772"/>
-              </a:lnSpc>
-              <a:spcBef>
-                <a:spcPts val="0"/>
-              </a:spcBef>
-              <a:spcAft>
-                <a:spcPts val="0"/>
-              </a:spcAft>
-              <a:defRPr sz="2100">
-                <a:solidFill>
-                  <a:srgbClr val="20344A"/>
-                </a:solidFill>
-                <a:latin typeface="Arial"/>
-              </a:defRPr>
-              <a:buChar char="•"/>
-            </a:pPr>
-            <a:r>
-              <a:rPr sz="2100" b="0" i="0">
-                <a:solidFill>
-                  <a:srgbClr val="20344A"/>
-                </a:solidFill>
-                <a:latin typeface="Arial"/>
-              </a:rPr>
-              <a:t>Pass requires every mandatory group row and every student's </a:t>
-            </a:r>
-            <a:br/>
-            <a:r>
-              <a:rPr sz="2100" b="0" i="0">
-                <a:solidFill>
-                  <a:srgbClr val="20344A"/>
-                </a:solidFill>
-                <a:latin typeface="Arial"/>
-              </a:rPr>
-              <a:t>individual participation requirement to pass.</a:t>
-            </a:r>
-          </a:p>
-        </p:txBody>
-      </p:sp>
-      <p:sp>
-        <p:nvSpPr>
-          <p:cNvPr id="8" name="content:line-168:0"/>
-          <p:cNvSpPr txBox="1"/>
-          <p:nvPr/>
-        </p:nvSpPr>
-        <p:spPr>
-          <a:xfrm>
-            <a:off x="594360" y="3425952"/>
-            <a:ext cx="11003279" cy="1132332"/>
-          </a:xfrm>
-          <a:prstGeom prst="rect">
-            <a:avLst/>
-          </a:prstGeom>
-          <a:noFill/>
-        </p:spPr>
-        <p:txBody>
-          <a:bodyPr wrap="none" anchor="t" lIns="88900" rIns="88900" tIns="38100" bIns="38100">
-            <a:noAutofit/>
-          </a:bodyPr>
-          <a:lstStyle/>
-          <a:p>
-            <a:pPr marL="279400" indent="-215900">
-              <a:lnSpc>
-                <a:spcPts val="2772"/>
-              </a:lnSpc>
-              <a:spcBef>
-                <a:spcPts val="0"/>
-              </a:spcBef>
-              <a:spcAft>
-                <a:spcPts val="0"/>
-              </a:spcAft>
-              <a:defRPr sz="2100">
-                <a:solidFill>
-                  <a:srgbClr val="20344A"/>
-                </a:solidFill>
-                <a:latin typeface="Arial"/>
-              </a:defRPr>
-              <a:buChar char="•"/>
-            </a:pPr>
-            <a:r>
-              <a:rPr sz="2100" b="0" i="0">
-                <a:solidFill>
-                  <a:srgbClr val="20344A"/>
-                </a:solidFill>
-                <a:latin typeface="Arial"/>
-              </a:rPr>
-              <a:t>Instructor records failed rows and reasons at the </a:t>
-            </a:r>
-            <a:br/>
-            <a:r>
-              <a:rPr sz="2100" b="0" i="0">
-                <a:solidFill>
-                  <a:srgbClr val="20344A"/>
-                </a:solidFill>
-                <a:latin typeface="Arial"/>
-              </a:rPr>
-              <a:t>presentation; no averaging or complexity bonuses, and no later </a:t>
-            </a:r>
-            <a:br/>
-            <a:r>
-              <a:rPr sz="2100" b="0" i="0">
-                <a:solidFill>
-                  <a:srgbClr val="20344A"/>
-                </a:solidFill>
-                <a:latin typeface="Arial"/>
-              </a:rPr>
               <a:t>retry.</a:t>
             </a:r>
           </a:p>
@@ -9381,7 +8955,7 @@
         </p:nvSpPr>
         <p:spPr>
           <a:xfrm>
-            <a:off x="594360" y="4622292"/>
+            <a:off x="594360" y="4974336"/>
             <a:ext cx="11003279" cy="780288"/>
           </a:xfrm>
           <a:prstGeom prst="rect">
@@ -9997,7 +9571,7 @@
         <p:spPr>
           <a:xfrm>
             <a:off x="594360" y="4622292"/>
-            <a:ext cx="11003279" cy="780288"/>
+            <a:ext cx="11003279" cy="1132332"/>
           </a:xfrm>
           <a:prstGeom prst="rect">
             <a:avLst/>
@@ -10054,7 +9628,17 @@
                 </a:solidFill>
                 <a:latin typeface="Arial"/>
               </a:rPr>
-              <a:t>Fix: tests.</a:t>
+              <a:t>Fix: tests, and a Release </a:t>
+            </a:r>
+            <a:br/>
+            <a:r>
+              <a:rPr sz="2100" b="1" i="0">
+                <a:solidFill>
+                  <a:srgbClr val="20344A"/>
+                </a:solidFill>
+                <a:latin typeface="Arial"/>
+              </a:rPr>
+              <a:t>others can install.</a:t>
             </a:r>
           </a:p>
         </p:txBody>
@@ -10067,8 +9651,8 @@
         </p:nvSpPr>
         <p:spPr>
           <a:xfrm>
-            <a:off x="594360" y="5466588"/>
-            <a:ext cx="11003279" cy="780288"/>
+            <a:off x="594360" y="5818632"/>
+            <a:ext cx="11003279" cy="428244"/>
           </a:xfrm>
           <a:prstGeom prst="rect">
             <a:avLst/>
@@ -10107,25 +9691,6 @@
                 <a:latin typeface="Arial"/>
               </a:rPr>
               <a:t>Stage 5 (Session 3): tests and CI; CI turns red on that </a:t>
-            </a:r>
-            <a:br/>
-            <a:r>
-              <a:rPr sz="2100" b="0" i="0">
-                <a:solidFill>
-                  <a:srgbClr val="20344A"/>
-                </a:solidFill>
-                <a:latin typeface="Arial"/>
-              </a:rPr>
-              <a:t>cleanup, but only programmers get a prediction. </a:t>
-            </a:r>
-            <a:r>
-              <a:rPr sz="2100" b="1" i="0">
-                <a:solidFill>
-                  <a:srgbClr val="20344A"/>
-                </a:solidFill>
-                <a:latin typeface="Arial"/>
-              </a:rPr>
-              <a:t>Fix: API and </a:t>
             </a:r>
           </a:p>
         </p:txBody>
@@ -10352,14 +9917,14 @@
       </p:sp>
       <p:sp>
         <p:nvSpPr>
-          <p:cNvPr id="6" name="content:line-22:2"/>
+          <p:cNvPr id="6" name="content:line-22:1"/>
           <p:cNvSpPr txBox="1"/>
           <p:nvPr/>
         </p:nvSpPr>
         <p:spPr>
           <a:xfrm>
             <a:off x="594360" y="1737360"/>
-            <a:ext cx="11003279" cy="428244"/>
+            <a:ext cx="11003279" cy="780288"/>
           </a:xfrm>
           <a:prstGeom prst="rect">
             <a:avLst/>
@@ -10391,12 +9956,31 @@
               <a:buChar char=" "/>
             </a:pPr>
             <a:r>
+              <a:rPr sz="2100" b="0" i="0">
+                <a:solidFill>
+                  <a:srgbClr val="20344A"/>
+                </a:solidFill>
+                <a:latin typeface="Arial"/>
+              </a:rPr>
+              <a:t>cleanup, but only programmers get a prediction. </a:t>
+            </a:r>
+            <a:r>
               <a:rPr sz="2100" b="1" i="0">
                 <a:solidFill>
                   <a:srgbClr val="20344A"/>
                 </a:solidFill>
                 <a:latin typeface="Arial"/>
               </a:rPr>
+              <a:t>Fix: API and </a:t>
+            </a:r>
+            <a:br/>
+            <a:r>
+              <a:rPr sz="2100" b="1" i="0">
+                <a:solidFill>
+                  <a:srgbClr val="20344A"/>
+                </a:solidFill>
+                <a:latin typeface="Arial"/>
+              </a:rPr>
               <a:t>UI.</a:t>
             </a:r>
           </a:p>
@@ -10410,7 +9994,7 @@
         </p:nvSpPr>
         <p:spPr>
           <a:xfrm>
-            <a:off x="594360" y="2229612"/>
+            <a:off x="594360" y="2581656"/>
             <a:ext cx="11003279" cy="780288"/>
           </a:xfrm>
           <a:prstGeom prst="rect">
@@ -10449,7 +10033,7 @@
                 </a:solidFill>
                 <a:latin typeface="Arial"/>
               </a:rPr>
-              <a:t>Stage 6 (Sessions 3–4): FastAPI and Streamlit; works only on </a:t>
+              <a:t>Stage 6 (Session 4): FastAPI and Streamlit; works only on a </a:t>
             </a:r>
             <a:br/>
             <a:r>
@@ -10459,7 +10043,7 @@
                 </a:solidFill>
                 <a:latin typeface="Arial"/>
               </a:rPr>
-              <a:t>a correctly set-up machine. </a:t>
+              <a:t>correctly set-up machine. </a:t>
             </a:r>
             <a:r>
               <a:rPr sz="2100" b="1" i="0">
@@ -10481,7 +10065,7 @@
         </p:nvSpPr>
         <p:spPr>
           <a:xfrm>
-            <a:off x="594360" y="3073908"/>
+            <a:off x="594360" y="3425952"/>
             <a:ext cx="11003279" cy="1132332"/>
           </a:xfrm>
           <a:prstGeom prst="rect">
@@ -10725,7 +10309,7 @@
                 </a:solidFill>
                 <a:latin typeface="Arial"/>
               </a:rPr>
-              <a:t>Our 180-minute showcase</a:t>
+              <a:t>Our 170-minute showcase</a:t>
             </a:r>
           </a:p>
         </p:txBody>
@@ -10822,7 +10406,7 @@
                 </a:solidFill>
                 <a:latin typeface="Arial"/>
               </a:rPr>
-              <a:t>Opening brief: 10 minutes. Group slots: 150 minutes in total.</a:t>
+              <a:t>Opening brief: 10 minutes. Group slots: 145 minutes in total.</a:t>
             </a:r>
           </a:p>
         </p:txBody>
@@ -10874,7 +10458,7 @@
                 </a:solidFill>
                 <a:latin typeface="Arial"/>
               </a:rPr>
-              <a:t>Shared break: 15 minutes between group slots. Closing: 5 </a:t>
+              <a:t>Shared break: 10 minutes between group slots. Closing: 5 </a:t>
             </a:r>
             <a:br/>
             <a:r>
@@ -10936,7 +10520,7 @@
                 </a:solidFill>
                 <a:latin typeface="Arial"/>
               </a:rPr>
-              <a:t>Let G be the actual number of groups; each slot is S = 150 / G </a:t>
+              <a:t>Let G be the actual number of groups; each slot is S = 145 / G </a:t>
             </a:r>
             <a:br/>
             <a:r>
@@ -10998,7 +10582,7 @@
                 </a:solidFill>
                 <a:latin typeface="Arial"/>
               </a:rPr>
-              <a:t>Total: 10 + G * S + 15 + 5 = 180 minutes.</a:t>
+              <a:t>Total: 10 + G * S + 10 + 5 = 170 minutes.</a:t>
             </a:r>
           </a:p>
         </p:txBody>
@@ -12287,7 +11871,7 @@
                 </a:solidFill>
                 <a:latin typeface="Arial"/>
               </a:rPr>
-              <a:t>Instructor demonstrates navigation using the completed </a:t>
+              <a:t>Instructor demonstrates navigation using a completed </a:t>
             </a:r>
             <a:br/>
             <a:r>
@@ -12297,7 +11881,7 @@
                 </a:solidFill>
                 <a:latin typeface="Arial"/>
               </a:rPr>
-              <a:t>synthetic example; groups then show their own work.</a:t>
+              <a:t>example Backend repo; groups then show their own work.</a:t>
             </a:r>
           </a:p>
         </p:txBody>
@@ -12359,7 +11943,7 @@
                 </a:solidFill>
                 <a:latin typeface="Arial"/>
               </a:rPr>
-              <a:t>captures/logs, authored PRs, and review permalinks. A SHA </a:t>
+              <a:t>captures/logs, authored PRs, review permalinks, and the </a:t>
             </a:r>
             <a:br/>
             <a:r>
@@ -12369,7 +11953,7 @@
                 </a:solidFill>
                 <a:latin typeface="Arial"/>
               </a:rPr>
-              <a:t>identifies a code version.</a:t>
+              <a:t>Release tag. A SHA identifies a code version.</a:t>
             </a:r>
           </a:p>
         </p:txBody>
@@ -12668,7 +12252,17 @@
                 </a:solidFill>
                 <a:latin typeface="Arial"/>
               </a:rPr>
-              <a:t>Inspect environment and configuration</a:t>
+              <a:t>Inspect environment, configuration, and </a:t>
+            </a:r>
+            <a:br/>
+            <a:r>
+              <a:rPr sz="3200" b="0" i="0">
+                <a:solidFill>
+                  <a:srgbClr val="20344A"/>
+                </a:solidFill>
+                <a:latin typeface="Arial"/>
+              </a:rPr>
+              <a:t>Releases</a:t>
             </a:r>
           </a:p>
         </p:txBody>
@@ -12765,7 +12359,7 @@
                 </a:solidFill>
                 <a:latin typeface="Arial"/>
               </a:rPr>
-              <a:t>Show Python 3.12 in an active venv, its interpreter path, and </a:t>
+              <a:t>Show Python 3.12 in an active venv and the installed package </a:t>
             </a:r>
             <a:br/>
             <a:r>
@@ -12775,7 +12369,7 @@
                 </a:solidFill>
                 <a:latin typeface="Arial"/>
               </a:rPr>
-              <a:t>the installed reusable package working locally.</a:t>
+              <a:t>working locally.</a:t>
             </a:r>
           </a:p>
         </p:txBody>
@@ -12827,26 +12421,25 @@
                 </a:solidFill>
                 <a:latin typeface="Arial"/>
               </a:rPr>
-              <a:t>Open dependency declarations in </a:t>
-            </a:r>
-            <a:r>
-              <a:rPr sz="2100" b="0" i="0">
-                <a:solidFill>
-                  <a:srgbClr val="007F82"/>
-                </a:solidFill>
-                <a:latin typeface="Arial"/>
-                <a:hlinkClick r:id="rId2"/>
-              </a:rPr>
-              <a:t>backend/pyproject.toml</a:t>
-            </a:r>
-            <a:r>
-              <a:rPr sz="2100" b="0" i="0">
-                <a:solidFill>
-                  <a:srgbClr val="20344A"/>
-                </a:solidFill>
-                <a:latin typeface="Arial"/>
-              </a:rPr>
-              <a:t>; </a:t>
+              <a:t>Open the dependency declarations in </a:t>
+            </a:r>
+            <a:r>
+              <a:rPr sz="2100" b="0" i="0">
+                <a:solidFill>
+                  <a:srgbClr val="20344A"/>
+                </a:solidFill>
+                <a:latin typeface="Courier New"/>
+              </a:rPr>
+              <a:t>setup.cfg</a:t>
+            </a:r>
+            <a:r>
+              <a:rPr sz="2100" b="0" i="0">
+                <a:solidFill>
+                  <a:srgbClr val="20344A"/>
+                </a:solidFill>
+                <a:latin typeface="Arial"/>
+              </a:rPr>
+              <a:t>; explain how the </a:t>
             </a:r>
             <a:br/>
             <a:r>
@@ -12856,7 +12449,7 @@
                 </a:solidFill>
                 <a:latin typeface="Arial"/>
               </a:rPr>
-              <a:t>explain how the environment supplies these packages.</a:t>
+              <a:t>environment supplies these packages.</a:t>
             </a:r>
           </a:p>
         </p:txBody>
@@ -12908,7 +12501,25 @@
                 </a:solidFill>
                 <a:latin typeface="Arial"/>
               </a:rPr>
-              <a:t>Open ignore rules and shareable .env.example; verify local .env, </a:t>
+              <a:t>Open ignore rules and the shareable </a:t>
+            </a:r>
+            <a:r>
+              <a:rPr sz="2100" b="0" i="0">
+                <a:solidFill>
+                  <a:srgbClr val="20344A"/>
+                </a:solidFill>
+                <a:latin typeface="Courier New"/>
+              </a:rPr>
+              <a:t>.env.example</a:t>
+            </a:r>
+            <a:r>
+              <a:rPr sz="2100" b="0" i="0">
+                <a:solidFill>
+                  <a:srgbClr val="20344A"/>
+                </a:solidFill>
+                <a:latin typeface="Arial"/>
+              </a:rPr>
+              <a:t>; verify local </a:t>
             </a:r>
             <a:br/>
             <a:r>
@@ -12916,9 +12527,36 @@
                 <a:solidFill>
                   <a:srgbClr val="20344A"/>
                 </a:solidFill>
-                <a:latin typeface="Arial"/>
-              </a:rPr>
-              <a:t>credentials, and .venv stay out of tracked files/history.</a:t>
+                <a:latin typeface="Courier New"/>
+              </a:rPr>
+              <a:t>.env</a:t>
+            </a:r>
+            <a:r>
+              <a:rPr sz="2100" b="0" i="0">
+                <a:solidFill>
+                  <a:srgbClr val="20344A"/>
+                </a:solidFill>
+                <a:latin typeface="Arial"/>
+              </a:rPr>
+              <a:t>, credentials, and </a:t>
+            </a:r>
+            <a:r>
+              <a:rPr sz="2100" b="0" i="0">
+                <a:solidFill>
+                  <a:srgbClr val="20344A"/>
+                </a:solidFill>
+                <a:latin typeface="Courier New"/>
+              </a:rPr>
+              <a:t>.venv</a:t>
+            </a:r>
+            <a:r>
+              <a:rPr sz="2100" b="0" i="0">
+                <a:solidFill>
+                  <a:srgbClr val="20344A"/>
+                </a:solidFill>
+                <a:latin typeface="Arial"/>
+              </a:rPr>
+              <a:t> stay out of tracked files/history.</a:t>
             </a:r>
           </a:p>
         </p:txBody>
@@ -12932,7 +12570,7 @@
         <p:spPr>
           <a:xfrm>
             <a:off x="594360" y="4270248"/>
-            <a:ext cx="11003279" cy="1132332"/>
+            <a:ext cx="11003279" cy="780288"/>
           </a:xfrm>
           <a:prstGeom prst="rect">
             <a:avLst/>
@@ -12970,7 +12608,7 @@
                 </a:solidFill>
                 <a:latin typeface="Arial"/>
               </a:rPr>
-              <a:t>Explain local versus container settings without showing </a:t>
+              <a:t>Show a tagged Release and install it from its git URL into a </a:t>
             </a:r>
             <a:br/>
             <a:r>
@@ -12980,27 +12618,7 @@
                 </a:solidFill>
                 <a:latin typeface="Arial"/>
               </a:rPr>
-              <a:t>secrets. Instructor inspects files and execution, alongside the </a:t>
-            </a:r>
-            <a:br/>
-            <a:r>
-              <a:rPr sz="2100" b="0" i="0">
-                <a:solidFill>
-                  <a:srgbClr val="007F82"/>
-                </a:solidFill>
-                <a:latin typeface="Arial"/>
-                <a:hlinkClick r:id="rId3"/>
-              </a:rPr>
-              <a:t>setup guide</a:t>
-            </a:r>
-            <a:r>
-              <a:rPr sz="2100" b="0" i="0">
-                <a:solidFill>
-                  <a:srgbClr val="20344A"/>
-                </a:solidFill>
-                <a:latin typeface="Arial"/>
-              </a:rPr>
-              <a:t>.</a:t>
+              <a:t>fresh virtual environment; run the command-line tool.</a:t>
             </a:r>
           </a:p>
         </p:txBody>

</xml_diff>